<commit_message>
Regenerate debrief deck for new data + per-category policy slide
- refresh demo-query slide to the new data (Dell XPS cancel, kurta ambiguity,
  per-category return windows, fraud-question vs report)
- add a slide on category-aware policy answers (14 categories, filter-before-
  truncate, category resolved from the in-context order)
- code snippets re-extracted live from current source; 25 slides

Co-Authored-By: Claude Opus 4.8 <noreply@anthropic.com>
</commit_message>
<xml_diff>
--- a/AtlasCare_Debrief.pptx
+++ b/AtlasCare_Debrief.pptx
@@ -29,6 +29,7 @@
     <p:sldId id="277" r:id="rId28"/>
     <p:sldId id="278" r:id="rId29"/>
     <p:sldId id="279" r:id="rId30"/>
+    <p:sldId id="280" r:id="rId31"/>
   </p:sldIdLst>
   <p:sldSz cx="12191695" cy="6858000" type="screen4x3"/>
   <p:notesSz cx="6858000" cy="9144000"/>
@@ -10883,7 +10884,7 @@
                 </a:solidFill>
                 <a:latin typeface="Calibri"/>
               </a:rPr>
-              <a:t>A general policy question is grounded in the KB articles we actually published and routed STRAIGHT to the responder — skipping the planner. Conservative: any order ID or action verb hands back to the planner.</a:t>
+              <a:t>A general policy question is grounded in the KB articles we actually published and routed STRAIGHT to the responder — skipping the planner. An informational question about unauthorised orders is answered (KB-003), NOT escalated as fraud; a real first-person report still escalates.</a:t>
             </a:r>
           </a:p>
         </p:txBody>
@@ -10917,7 +10918,7 @@
                 </a:solidFill>
                 <a:latin typeface="Calibri"/>
               </a:rPr>
-              <a:t>conservative classifier</a:t>
+              <a:t>conservative classifier (+ fraud-question topics)</a:t>
             </a:r>
           </a:p>
         </p:txBody>
@@ -11565,6 +11566,28 @@
                 </a:solidFill>
                 <a:latin typeface="Consolas"/>
               </a:rPr>
+              <a:t>    # ... (continues in source)</a:t>
+            </a:r>
+          </a:p>
+          <a:p>
+            <a:pPr>
+              <a:lnSpc>
+                <a:spcPct val="100000"/>
+              </a:lnSpc>
+              <a:spcBef>
+                <a:spcPts val="0"/>
+              </a:spcBef>
+              <a:spcAft>
+                <a:spcPts val="0"/>
+              </a:spcAft>
+            </a:pPr>
+            <a:r>
+              <a:rPr sz="1200" b="0" i="0">
+                <a:solidFill>
+                  <a:srgbClr val="CDD6F4"/>
+                </a:solidFill>
+                <a:latin typeface="Consolas"/>
+              </a:rPr>
               <a:t> </a:t>
             </a:r>
           </a:p>
@@ -11667,6 +11690,1044 @@
 </file>
 
 <file path=ppt/slides/slide21.xml><?xml version="1.0" encoding="utf-8"?>
+<p:sld xmlns:a="http://schemas.openxmlformats.org/drawingml/2006/main" xmlns:p="http://schemas.openxmlformats.org/presentationml/2006/main" xmlns:r="http://schemas.openxmlformats.org/officeDocument/2006/relationships">
+  <p:cSld>
+    <p:spTree>
+      <p:nvGrpSpPr>
+        <p:cNvPr id="1" name=""/>
+        <p:cNvGrpSpPr/>
+        <p:nvPr/>
+      </p:nvGrpSpPr>
+      <p:grpSpPr/>
+      <p:sp>
+        <p:nvSpPr>
+          <p:cNvPr id="2" name="Rectangle 1"/>
+          <p:cNvSpPr/>
+          <p:nvPr/>
+        </p:nvSpPr>
+        <p:spPr>
+          <a:xfrm>
+            <a:off x="0" y="0"/>
+            <a:ext cx="12191695" cy="960120"/>
+          </a:xfrm>
+          <a:prstGeom prst="rect">
+            <a:avLst/>
+          </a:prstGeom>
+          <a:solidFill>
+            <a:srgbClr val="1F3A5F"/>
+          </a:solidFill>
+          <a:ln>
+            <a:noFill/>
+          </a:ln>
+          <a:effectLst/>
+        </p:spPr>
+        <p:style>
+          <a:lnRef idx="1">
+            <a:schemeClr val="accent1"/>
+          </a:lnRef>
+          <a:fillRef idx="3">
+            <a:schemeClr val="accent1"/>
+          </a:fillRef>
+          <a:effectRef idx="2">
+            <a:schemeClr val="accent1"/>
+          </a:effectRef>
+          <a:fontRef idx="minor">
+            <a:schemeClr val="lt1"/>
+          </a:fontRef>
+        </p:style>
+        <p:txBody>
+          <a:bodyPr rtlCol="0" anchor="ctr" lIns="365760" tIns="109728" wrap="square"/>
+          <a:lstStyle/>
+          <a:p>
+            <a:pPr algn="ctr"/>
+            <a:r>
+              <a:rPr sz="2600" b="1" i="0">
+                <a:solidFill>
+                  <a:srgbClr val="FFFFFF"/>
+                </a:solidFill>
+                <a:latin typeface="Calibri"/>
+              </a:rPr>
+              <a:t>Policy answers that know the product category</a:t>
+            </a:r>
+          </a:p>
+        </p:txBody>
+      </p:sp>
+      <p:sp>
+        <p:nvSpPr>
+          <p:cNvPr id="3" name="Rectangle 2"/>
+          <p:cNvSpPr/>
+          <p:nvPr/>
+        </p:nvSpPr>
+        <p:spPr>
+          <a:xfrm>
+            <a:off x="0" y="960120"/>
+            <a:ext cx="12191695" cy="54864"/>
+          </a:xfrm>
+          <a:prstGeom prst="rect">
+            <a:avLst/>
+          </a:prstGeom>
+          <a:solidFill>
+            <a:srgbClr val="4C8BF5"/>
+          </a:solidFill>
+          <a:ln>
+            <a:noFill/>
+          </a:ln>
+          <a:effectLst/>
+        </p:spPr>
+        <p:style>
+          <a:lnRef idx="1">
+            <a:schemeClr val="accent1"/>
+          </a:lnRef>
+          <a:fillRef idx="3">
+            <a:schemeClr val="accent1"/>
+          </a:fillRef>
+          <a:effectRef idx="2">
+            <a:schemeClr val="accent1"/>
+          </a:effectRef>
+          <a:fontRef idx="minor">
+            <a:schemeClr val="lt1"/>
+          </a:fontRef>
+        </p:style>
+        <p:txBody>
+          <a:bodyPr rtlCol="0" anchor="ctr"/>
+          <a:lstStyle/>
+          <a:p>
+            <a:pPr algn="ctr"/>
+          </a:p>
+        </p:txBody>
+      </p:sp>
+      <p:sp>
+        <p:nvSpPr>
+          <p:cNvPr id="4" name="Rounded Rectangle 3"/>
+          <p:cNvSpPr/>
+          <p:nvPr/>
+        </p:nvSpPr>
+        <p:spPr>
+          <a:xfrm>
+            <a:off x="10554919" y="301752"/>
+            <a:ext cx="1316736" cy="384048"/>
+          </a:xfrm>
+          <a:prstGeom prst="roundRect">
+            <a:avLst/>
+          </a:prstGeom>
+          <a:solidFill>
+            <a:srgbClr val="4C8BF5"/>
+          </a:solidFill>
+          <a:ln>
+            <a:noFill/>
+          </a:ln>
+          <a:effectLst/>
+        </p:spPr>
+        <p:style>
+          <a:lnRef idx="1">
+            <a:schemeClr val="accent1"/>
+          </a:lnRef>
+          <a:fillRef idx="3">
+            <a:schemeClr val="accent1"/>
+          </a:fillRef>
+          <a:effectRef idx="2">
+            <a:schemeClr val="accent1"/>
+          </a:effectRef>
+          <a:fontRef idx="minor">
+            <a:schemeClr val="lt1"/>
+          </a:fontRef>
+        </p:style>
+        <p:txBody>
+          <a:bodyPr rtlCol="0" anchor="ctr" tIns="0" bIns="0"/>
+          <a:lstStyle/>
+          <a:p>
+            <a:pPr algn="ctr"/>
+            <a:r>
+              <a:rPr sz="1200" b="1" i="0">
+                <a:solidFill>
+                  <a:srgbClr val="FFFFFF"/>
+                </a:solidFill>
+                <a:latin typeface="Calibri"/>
+              </a:rPr>
+              <a:t>ARCHITECTURE</a:t>
+            </a:r>
+          </a:p>
+        </p:txBody>
+      </p:sp>
+      <p:sp>
+        <p:nvSpPr>
+          <p:cNvPr id="5" name="TextBox 4"/>
+          <p:cNvSpPr txBox="1"/>
+          <p:nvPr/>
+        </p:nvSpPr>
+        <p:spPr>
+          <a:xfrm>
+            <a:off x="411480" y="1143000"/>
+            <a:ext cx="11368735" cy="640080"/>
+          </a:xfrm>
+          <a:prstGeom prst="rect">
+            <a:avLst/>
+          </a:prstGeom>
+          <a:noFill/>
+        </p:spPr>
+        <p:txBody>
+          <a:bodyPr wrap="square">
+            <a:spAutoFit/>
+          </a:bodyPr>
+          <a:lstStyle/>
+          <a:p>
+            <a:r>
+              <a:rPr sz="1500" b="0" i="1">
+                <a:solidFill>
+                  <a:srgbClr val="555B66"/>
+                </a:solidFill>
+                <a:latin typeface="Calibri"/>
+              </a:rPr>
+              <a:t>14 categories (electronics, apparel, footwear, beauty, jewelry, … + misc), derived from kb_articles.applies_to — NOT hardcoded. Return windows differ: electronics 7d, apparel 30d, footwear 14d, beauty non-returnable, jewelry 15d. The in-context order's category picks the right policy.</a:t>
+            </a:r>
+          </a:p>
+        </p:txBody>
+      </p:sp>
+      <p:sp>
+        <p:nvSpPr>
+          <p:cNvPr id="6" name="TextBox 5"/>
+          <p:cNvSpPr txBox="1"/>
+          <p:nvPr/>
+        </p:nvSpPr>
+        <p:spPr>
+          <a:xfrm>
+            <a:off x="411480" y="1143000"/>
+            <a:ext cx="5547207" cy="548640"/>
+          </a:xfrm>
+          <a:prstGeom prst="rect">
+            <a:avLst/>
+          </a:prstGeom>
+          <a:noFill/>
+        </p:spPr>
+        <p:txBody>
+          <a:bodyPr wrap="none">
+            <a:spAutoFit/>
+          </a:bodyPr>
+          <a:lstStyle/>
+          <a:p>
+            <a:r>
+              <a:rPr sz="1300" b="0" i="1">
+                <a:solidFill>
+                  <a:srgbClr val="555B66"/>
+                </a:solidFill>
+                <a:latin typeface="Calibri"/>
+              </a:rPr>
+              <a:t>filter the FULL candidate set, then truncate</a:t>
+            </a:r>
+          </a:p>
+        </p:txBody>
+      </p:sp>
+      <p:sp>
+        <p:nvSpPr>
+          <p:cNvPr id="7" name="TextBox 6"/>
+          <p:cNvSpPr txBox="1"/>
+          <p:nvPr/>
+        </p:nvSpPr>
+        <p:spPr>
+          <a:xfrm>
+            <a:off x="6370167" y="1143000"/>
+            <a:ext cx="5547207" cy="548640"/>
+          </a:xfrm>
+          <a:prstGeom prst="rect">
+            <a:avLst/>
+          </a:prstGeom>
+          <a:noFill/>
+        </p:spPr>
+        <p:txBody>
+          <a:bodyPr wrap="none">
+            <a:spAutoFit/>
+          </a:bodyPr>
+          <a:lstStyle/>
+          <a:p>
+            <a:r>
+              <a:rPr sz="1300" b="0" i="1">
+                <a:solidFill>
+                  <a:srgbClr val="555B66"/>
+                </a:solidFill>
+                <a:latin typeface="Calibri"/>
+              </a:rPr>
+              <a:t>category from the in-context order</a:t>
+            </a:r>
+          </a:p>
+        </p:txBody>
+      </p:sp>
+      <p:sp>
+        <p:nvSpPr>
+          <p:cNvPr id="8" name="Rounded Rectangle 7"/>
+          <p:cNvSpPr/>
+          <p:nvPr/>
+        </p:nvSpPr>
+        <p:spPr>
+          <a:xfrm>
+            <a:off x="411480" y="1783080"/>
+            <a:ext cx="5547207" cy="4754880"/>
+          </a:xfrm>
+          <a:prstGeom prst="roundRect">
+            <a:avLst/>
+          </a:prstGeom>
+          <a:solidFill>
+            <a:srgbClr val="1E1E2E"/>
+          </a:solidFill>
+          <a:ln w="9525">
+            <a:solidFill>
+              <a:srgbClr val="4C8BF5"/>
+            </a:solidFill>
+          </a:ln>
+          <a:effectLst/>
+        </p:spPr>
+        <p:style>
+          <a:lnRef idx="1">
+            <a:schemeClr val="accent1"/>
+          </a:lnRef>
+          <a:fillRef idx="3">
+            <a:schemeClr val="accent1"/>
+          </a:fillRef>
+          <a:effectRef idx="2">
+            <a:schemeClr val="accent1"/>
+          </a:effectRef>
+          <a:fontRef idx="minor">
+            <a:schemeClr val="lt1"/>
+          </a:fontRef>
+        </p:style>
+        <p:txBody>
+          <a:bodyPr rtlCol="0" anchor="t" wrap="none" lIns="201168" rIns="137160" tIns="109728" bIns="91440"/>
+          <a:lstStyle/>
+          <a:p>
+            <a:pPr algn="ctr">
+              <a:lnSpc>
+                <a:spcPct val="100000"/>
+              </a:lnSpc>
+              <a:spcBef>
+                <a:spcPts val="0"/>
+              </a:spcBef>
+              <a:spcAft>
+                <a:spcPts val="0"/>
+              </a:spcAft>
+            </a:pPr>
+            <a:r>
+              <a:rPr sz="1200" b="0" i="0">
+                <a:solidFill>
+                  <a:srgbClr val="CDD6F4"/>
+                </a:solidFill>
+                <a:latin typeface="Consolas"/>
+              </a:rPr>
+              <a:t>def _filter_articles_by_category(articles: list[dict], categories: list[str]) -&gt; list[dict]:</a:t>
+            </a:r>
+          </a:p>
+          <a:p>
+            <a:pPr>
+              <a:lnSpc>
+                <a:spcPct val="100000"/>
+              </a:lnSpc>
+              <a:spcBef>
+                <a:spcPts val="0"/>
+              </a:spcBef>
+              <a:spcAft>
+                <a:spcPts val="0"/>
+              </a:spcAft>
+            </a:pPr>
+            <a:r>
+              <a:rPr sz="1200" b="0" i="0">
+                <a:solidFill>
+                  <a:srgbClr val="CDD6F4"/>
+                </a:solidFill>
+                <a:latin typeface="Consolas"/>
+              </a:rPr>
+              <a:t>    """Keep only articles whose `applies_to` intersects the product categories in</a:t>
+            </a:r>
+          </a:p>
+          <a:p>
+            <a:pPr>
+              <a:lnSpc>
+                <a:spcPct val="100000"/>
+              </a:lnSpc>
+              <a:spcBef>
+                <a:spcPts val="0"/>
+              </a:spcBef>
+              <a:spcAft>
+                <a:spcPts val="0"/>
+              </a:spcAft>
+            </a:pPr>
+            <a:r>
+              <a:rPr sz="1200" b="0" i="0">
+                <a:solidFill>
+                  <a:srgbClr val="CDD6F4"/>
+                </a:solidFill>
+                <a:latin typeface="Consolas"/>
+              </a:rPr>
+              <a:t>    context — so the graph selects policy by BOTH tag relevance and product</a:t>
+            </a:r>
+          </a:p>
+          <a:p>
+            <a:pPr>
+              <a:lnSpc>
+                <a:spcPct val="100000"/>
+              </a:lnSpc>
+              <a:spcBef>
+                <a:spcPts val="0"/>
+              </a:spcBef>
+              <a:spcAft>
+                <a:spcPts val="0"/>
+              </a:spcAft>
+            </a:pPr>
+            <a:r>
+              <a:rPr sz="1200" b="0" i="0">
+                <a:solidFill>
+                  <a:srgbClr val="CDD6F4"/>
+                </a:solidFill>
+                <a:latin typeface="Consolas"/>
+              </a:rPr>
+              <a:t>    category. Never returns empty solely because of the category filter: if the</a:t>
+            </a:r>
+          </a:p>
+          <a:p>
+            <a:pPr>
+              <a:lnSpc>
+                <a:spcPct val="100000"/>
+              </a:lnSpc>
+              <a:spcBef>
+                <a:spcPts val="0"/>
+              </a:spcBef>
+              <a:spcAft>
+                <a:spcPts val="0"/>
+              </a:spcAft>
+            </a:pPr>
+            <a:r>
+              <a:rPr sz="1200" b="0" i="0">
+                <a:solidFill>
+                  <a:srgbClr val="CDD6F4"/>
+                </a:solidFill>
+                <a:latin typeface="Consolas"/>
+              </a:rPr>
+              <a:t>    filter would drop everything, the tag-ranked list is returned unchanged (a</a:t>
+            </a:r>
+          </a:p>
+          <a:p>
+            <a:pPr>
+              <a:lnSpc>
+                <a:spcPct val="100000"/>
+              </a:lnSpc>
+              <a:spcBef>
+                <a:spcPts val="0"/>
+              </a:spcBef>
+              <a:spcAft>
+                <a:spcPts val="0"/>
+              </a:spcAft>
+            </a:pPr>
+            <a:r>
+              <a:rPr sz="1200" b="0" i="0">
+                <a:solidFill>
+                  <a:srgbClr val="CDD6F4"/>
+                </a:solidFill>
+                <a:latin typeface="Consolas"/>
+              </a:rPr>
+              <a:t>    relevant-by-tag article missing applies_to should still surface)."""</a:t>
+            </a:r>
+          </a:p>
+          <a:p>
+            <a:pPr>
+              <a:lnSpc>
+                <a:spcPct val="100000"/>
+              </a:lnSpc>
+              <a:spcBef>
+                <a:spcPts val="0"/>
+              </a:spcBef>
+              <a:spcAft>
+                <a:spcPts val="0"/>
+              </a:spcAft>
+            </a:pPr>
+            <a:r>
+              <a:rPr sz="1200" b="0" i="0">
+                <a:solidFill>
+                  <a:srgbClr val="CDD6F4"/>
+                </a:solidFill>
+                <a:latin typeface="Consolas"/>
+              </a:rPr>
+              <a:t>    if not categories:</a:t>
+            </a:r>
+          </a:p>
+          <a:p>
+            <a:pPr>
+              <a:lnSpc>
+                <a:spcPct val="100000"/>
+              </a:lnSpc>
+              <a:spcBef>
+                <a:spcPts val="0"/>
+              </a:spcBef>
+              <a:spcAft>
+                <a:spcPts val="0"/>
+              </a:spcAft>
+            </a:pPr>
+            <a:r>
+              <a:rPr sz="1200" b="0" i="0">
+                <a:solidFill>
+                  <a:srgbClr val="CDD6F4"/>
+                </a:solidFill>
+                <a:latin typeface="Consolas"/>
+              </a:rPr>
+              <a:t>        return articles</a:t>
+            </a:r>
+          </a:p>
+          <a:p>
+            <a:pPr>
+              <a:lnSpc>
+                <a:spcPct val="100000"/>
+              </a:lnSpc>
+              <a:spcBef>
+                <a:spcPts val="0"/>
+              </a:spcBef>
+              <a:spcAft>
+                <a:spcPts val="0"/>
+              </a:spcAft>
+            </a:pPr>
+            <a:r>
+              <a:rPr sz="1200" b="0" i="0">
+                <a:solidFill>
+                  <a:srgbClr val="CDD6F4"/>
+                </a:solidFill>
+                <a:latin typeface="Consolas"/>
+              </a:rPr>
+              <a:t>    cats = set(categories)</a:t>
+            </a:r>
+          </a:p>
+          <a:p>
+            <a:pPr>
+              <a:lnSpc>
+                <a:spcPct val="100000"/>
+              </a:lnSpc>
+              <a:spcBef>
+                <a:spcPts val="0"/>
+              </a:spcBef>
+              <a:spcAft>
+                <a:spcPts val="0"/>
+              </a:spcAft>
+            </a:pPr>
+            <a:r>
+              <a:rPr sz="1200" b="0" i="0">
+                <a:solidFill>
+                  <a:srgbClr val="CDD6F4"/>
+                </a:solidFill>
+                <a:latin typeface="Consolas"/>
+              </a:rPr>
+              <a:t>    filtered = [a for a in articles if set(a.get("applies_to", []) or []) &amp; cats]</a:t>
+            </a:r>
+          </a:p>
+          <a:p>
+            <a:pPr>
+              <a:lnSpc>
+                <a:spcPct val="100000"/>
+              </a:lnSpc>
+              <a:spcBef>
+                <a:spcPts val="0"/>
+              </a:spcBef>
+              <a:spcAft>
+                <a:spcPts val="0"/>
+              </a:spcAft>
+            </a:pPr>
+            <a:r>
+              <a:rPr sz="1200" b="0" i="0">
+                <a:solidFill>
+                  <a:srgbClr val="CDD6F4"/>
+                </a:solidFill>
+                <a:latin typeface="Consolas"/>
+              </a:rPr>
+              <a:t>    return filtered or articles</a:t>
+            </a:r>
+          </a:p>
+          <a:p>
+            <a:pPr>
+              <a:lnSpc>
+                <a:spcPct val="100000"/>
+              </a:lnSpc>
+              <a:spcBef>
+                <a:spcPts val="0"/>
+              </a:spcBef>
+              <a:spcAft>
+                <a:spcPts val="0"/>
+              </a:spcAft>
+            </a:pPr>
+            <a:r>
+              <a:rPr sz="1200" b="0" i="0">
+                <a:solidFill>
+                  <a:srgbClr val="CDD6F4"/>
+                </a:solidFill>
+                <a:latin typeface="Consolas"/>
+              </a:rPr>
+              <a:t>    # ... (continues in source)</a:t>
+            </a:r>
+          </a:p>
+        </p:txBody>
+      </p:sp>
+      <p:sp>
+        <p:nvSpPr>
+          <p:cNvPr id="9" name="Rounded Rectangle 8"/>
+          <p:cNvSpPr/>
+          <p:nvPr/>
+        </p:nvSpPr>
+        <p:spPr>
+          <a:xfrm>
+            <a:off x="6370167" y="1783080"/>
+            <a:ext cx="5547207" cy="4754880"/>
+          </a:xfrm>
+          <a:prstGeom prst="roundRect">
+            <a:avLst/>
+          </a:prstGeom>
+          <a:solidFill>
+            <a:srgbClr val="1E1E2E"/>
+          </a:solidFill>
+          <a:ln w="9525">
+            <a:solidFill>
+              <a:srgbClr val="4C8BF5"/>
+            </a:solidFill>
+          </a:ln>
+          <a:effectLst/>
+        </p:spPr>
+        <p:style>
+          <a:lnRef idx="1">
+            <a:schemeClr val="accent1"/>
+          </a:lnRef>
+          <a:fillRef idx="3">
+            <a:schemeClr val="accent1"/>
+          </a:fillRef>
+          <a:effectRef idx="2">
+            <a:schemeClr val="accent1"/>
+          </a:effectRef>
+          <a:fontRef idx="minor">
+            <a:schemeClr val="lt1"/>
+          </a:fontRef>
+        </p:style>
+        <p:txBody>
+          <a:bodyPr rtlCol="0" anchor="t" wrap="none" lIns="201168" rIns="137160" tIns="109728" bIns="91440"/>
+          <a:lstStyle/>
+          <a:p>
+            <a:pPr algn="ctr">
+              <a:lnSpc>
+                <a:spcPct val="100000"/>
+              </a:lnSpc>
+              <a:spcBef>
+                <a:spcPts val="0"/>
+              </a:spcBef>
+              <a:spcAft>
+                <a:spcPts val="0"/>
+              </a:spcAft>
+            </a:pPr>
+            <a:r>
+              <a:rPr sz="1200" b="0" i="0">
+                <a:solidFill>
+                  <a:srgbClr val="CDD6F4"/>
+                </a:solidFill>
+                <a:latin typeface="Consolas"/>
+              </a:rPr>
+              <a:t>async def _resolve_context_categories(state: AtlasCareState) -&gt; list[str]:</a:t>
+            </a:r>
+          </a:p>
+          <a:p>
+            <a:pPr>
+              <a:lnSpc>
+                <a:spcPct val="100000"/>
+              </a:lnSpc>
+              <a:spcBef>
+                <a:spcPts val="0"/>
+              </a:spcBef>
+              <a:spcAft>
+                <a:spcPts val="0"/>
+              </a:spcAft>
+            </a:pPr>
+            <a:r>
+              <a:rPr sz="1200" b="0" i="0">
+                <a:solidFill>
+                  <a:srgbClr val="CDD6F4"/>
+                </a:solidFill>
+                <a:latin typeface="Consolas"/>
+              </a:rPr>
+              <a:t>    """Product categories of any order referenced in this turn's conversation,</a:t>
+            </a:r>
+          </a:p>
+          <a:p>
+            <a:pPr>
+              <a:lnSpc>
+                <a:spcPct val="100000"/>
+              </a:lnSpc>
+              <a:spcBef>
+                <a:spcPts val="0"/>
+              </a:spcBef>
+              <a:spcAft>
+                <a:spcPts val="0"/>
+              </a:spcAft>
+            </a:pPr>
+            <a:r>
+              <a:rPr sz="1200" b="0" i="0">
+                <a:solidFill>
+                  <a:srgbClr val="CDD6F4"/>
+                </a:solidFill>
+                <a:latin typeface="Consolas"/>
+              </a:rPr>
+              <a:t>    via the derived product-&gt;category map. Ownership-checked: only the session's</a:t>
+            </a:r>
+          </a:p>
+          <a:p>
+            <a:pPr>
+              <a:lnSpc>
+                <a:spcPct val="100000"/>
+              </a:lnSpc>
+              <a:spcBef>
+                <a:spcPts val="0"/>
+              </a:spcBef>
+              <a:spcAft>
+                <a:spcPts val="0"/>
+              </a:spcAft>
+            </a:pPr>
+            <a:r>
+              <a:rPr sz="1200" b="0" i="0">
+                <a:solidFill>
+                  <a:srgbClr val="CDD6F4"/>
+                </a:solidFill>
+                <a:latin typeface="Consolas"/>
+              </a:rPr>
+              <a:t>    own orders contribute. Empty when no order is in context or the map is absent."""</a:t>
+            </a:r>
+          </a:p>
+          <a:p>
+            <a:pPr>
+              <a:lnSpc>
+                <a:spcPct val="100000"/>
+              </a:lnSpc>
+              <a:spcBef>
+                <a:spcPts val="0"/>
+              </a:spcBef>
+              <a:spcAft>
+                <a:spcPts val="0"/>
+              </a:spcAft>
+            </a:pPr>
+            <a:r>
+              <a:rPr sz="1200" b="0" i="0">
+                <a:solidFill>
+                  <a:srgbClr val="CDD6F4"/>
+                </a:solidFill>
+                <a:latin typeface="Consolas"/>
+              </a:rPr>
+              <a:t>    text = " ".join(</a:t>
+            </a:r>
+          </a:p>
+          <a:p>
+            <a:pPr>
+              <a:lnSpc>
+                <a:spcPct val="100000"/>
+              </a:lnSpc>
+              <a:spcBef>
+                <a:spcPts val="0"/>
+              </a:spcBef>
+              <a:spcAft>
+                <a:spcPts val="0"/>
+              </a:spcAft>
+            </a:pPr>
+            <a:r>
+              <a:rPr sz="1200" b="0" i="0">
+                <a:solidFill>
+                  <a:srgbClr val="CDD6F4"/>
+                </a:solidFill>
+                <a:latin typeface="Consolas"/>
+              </a:rPr>
+              <a:t>        m["content"] for m in state.get("messages", [])</a:t>
+            </a:r>
+          </a:p>
+          <a:p>
+            <a:pPr>
+              <a:lnSpc>
+                <a:spcPct val="100000"/>
+              </a:lnSpc>
+              <a:spcBef>
+                <a:spcPts val="0"/>
+              </a:spcBef>
+              <a:spcAft>
+                <a:spcPts val="0"/>
+              </a:spcAft>
+            </a:pPr>
+            <a:r>
+              <a:rPr sz="1200" b="0" i="0">
+                <a:solidFill>
+                  <a:srgbClr val="CDD6F4"/>
+                </a:solidFill>
+                <a:latin typeface="Consolas"/>
+              </a:rPr>
+              <a:t>        if isinstance(m.get("content"), str)</a:t>
+            </a:r>
+          </a:p>
+          <a:p>
+            <a:pPr>
+              <a:lnSpc>
+                <a:spcPct val="100000"/>
+              </a:lnSpc>
+              <a:spcBef>
+                <a:spcPts val="0"/>
+              </a:spcBef>
+              <a:spcAft>
+                <a:spcPts val="0"/>
+              </a:spcAft>
+            </a:pPr>
+            <a:r>
+              <a:rPr sz="1200" b="0" i="0">
+                <a:solidFill>
+                  <a:srgbClr val="CDD6F4"/>
+                </a:solidFill>
+                <a:latin typeface="Consolas"/>
+              </a:rPr>
+              <a:t>    )</a:t>
+            </a:r>
+          </a:p>
+          <a:p>
+            <a:pPr>
+              <a:lnSpc>
+                <a:spcPct val="100000"/>
+              </a:lnSpc>
+              <a:spcBef>
+                <a:spcPts val="0"/>
+              </a:spcBef>
+              <a:spcAft>
+                <a:spcPts val="0"/>
+              </a:spcAft>
+            </a:pPr>
+            <a:r>
+              <a:rPr sz="1200" b="0" i="0">
+                <a:solidFill>
+                  <a:srgbClr val="CDD6F4"/>
+                </a:solidFill>
+                <a:latin typeface="Consolas"/>
+              </a:rPr>
+              <a:t>    cats: list[str] = []</a:t>
+            </a:r>
+          </a:p>
+          <a:p>
+            <a:pPr>
+              <a:lnSpc>
+                <a:spcPct val="100000"/>
+              </a:lnSpc>
+              <a:spcBef>
+                <a:spcPts val="0"/>
+              </a:spcBef>
+              <a:spcAft>
+                <a:spcPts val="0"/>
+              </a:spcAft>
+            </a:pPr>
+            <a:r>
+              <a:rPr sz="1200" b="0" i="0">
+                <a:solidFill>
+                  <a:srgbClr val="CDD6F4"/>
+                </a:solidFill>
+                <a:latin typeface="Consolas"/>
+              </a:rPr>
+              <a:t>    for oid in _extract_order_ids(text)[-3:]:</a:t>
+            </a:r>
+          </a:p>
+          <a:p>
+            <a:pPr>
+              <a:lnSpc>
+                <a:spcPct val="100000"/>
+              </a:lnSpc>
+              <a:spcBef>
+                <a:spcPts val="0"/>
+              </a:spcBef>
+              <a:spcAft>
+                <a:spcPts val="0"/>
+              </a:spcAft>
+            </a:pPr>
+            <a:r>
+              <a:rPr sz="1200" b="0" i="0">
+                <a:solidFill>
+                  <a:srgbClr val="CDD6F4"/>
+                </a:solidFill>
+                <a:latin typeface="Consolas"/>
+              </a:rPr>
+              <a:t>        try:</a:t>
+            </a:r>
+          </a:p>
+          <a:p>
+            <a:pPr>
+              <a:lnSpc>
+                <a:spcPct val="100000"/>
+              </a:lnSpc>
+              <a:spcBef>
+                <a:spcPts val="0"/>
+              </a:spcBef>
+              <a:spcAft>
+                <a:spcPts val="0"/>
+              </a:spcAft>
+            </a:pPr>
+            <a:r>
+              <a:rPr sz="1200" b="0" i="0">
+                <a:solidFill>
+                  <a:srgbClr val="CDD6F4"/>
+                </a:solidFill>
+                <a:latin typeface="Consolas"/>
+              </a:rPr>
+              <a:t>            order = await _fetch_owned_order(oid, state["customer_id"])</a:t>
+            </a:r>
+          </a:p>
+          <a:p>
+            <a:pPr>
+              <a:lnSpc>
+                <a:spcPct val="100000"/>
+              </a:lnSpc>
+              <a:spcBef>
+                <a:spcPts val="0"/>
+              </a:spcBef>
+              <a:spcAft>
+                <a:spcPts val="0"/>
+              </a:spcAft>
+            </a:pPr>
+            <a:r>
+              <a:rPr sz="1200" b="0" i="0">
+                <a:solidFill>
+                  <a:srgbClr val="CDD6F4"/>
+                </a:solidFill>
+                <a:latin typeface="Consolas"/>
+              </a:rPr>
+              <a:t>        except Exception:</a:t>
+            </a:r>
+          </a:p>
+          <a:p>
+            <a:pPr>
+              <a:lnSpc>
+                <a:spcPct val="100000"/>
+              </a:lnSpc>
+              <a:spcBef>
+                <a:spcPts val="0"/>
+              </a:spcBef>
+              <a:spcAft>
+                <a:spcPts val="0"/>
+              </a:spcAft>
+            </a:pPr>
+            <a:r>
+              <a:rPr sz="1200" b="0" i="0">
+                <a:solidFill>
+                  <a:srgbClr val="CDD6F4"/>
+                </a:solidFill>
+                <a:latin typeface="Consolas"/>
+              </a:rPr>
+              <a:t>            continue</a:t>
+            </a:r>
+          </a:p>
+          <a:p>
+            <a:pPr>
+              <a:lnSpc>
+                <a:spcPct val="100000"/>
+              </a:lnSpc>
+              <a:spcBef>
+                <a:spcPts val="0"/>
+              </a:spcBef>
+              <a:spcAft>
+                <a:spcPts val="0"/>
+              </a:spcAft>
+            </a:pPr>
+            <a:r>
+              <a:rPr sz="1200" b="0" i="0">
+                <a:solidFill>
+                  <a:srgbClr val="CDD6F4"/>
+                </a:solidFill>
+                <a:latin typeface="Consolas"/>
+              </a:rPr>
+              <a:t>        for c in _categories.categories_for_order(order):</a:t>
+            </a:r>
+          </a:p>
+          <a:p>
+            <a:pPr>
+              <a:lnSpc>
+                <a:spcPct val="100000"/>
+              </a:lnSpc>
+              <a:spcBef>
+                <a:spcPts val="0"/>
+              </a:spcBef>
+              <a:spcAft>
+                <a:spcPts val="0"/>
+              </a:spcAft>
+            </a:pPr>
+            <a:r>
+              <a:rPr sz="1200" b="0" i="0">
+                <a:solidFill>
+                  <a:srgbClr val="CDD6F4"/>
+                </a:solidFill>
+                <a:latin typeface="Consolas"/>
+              </a:rPr>
+              <a:t>            if c not in cats:</a:t>
+            </a:r>
+          </a:p>
+          <a:p>
+            <a:pPr>
+              <a:lnSpc>
+                <a:spcPct val="100000"/>
+              </a:lnSpc>
+              <a:spcBef>
+                <a:spcPts val="0"/>
+              </a:spcBef>
+              <a:spcAft>
+                <a:spcPts val="0"/>
+              </a:spcAft>
+            </a:pPr>
+            <a:r>
+              <a:rPr sz="1200" b="0" i="0">
+                <a:solidFill>
+                  <a:srgbClr val="CDD6F4"/>
+                </a:solidFill>
+                <a:latin typeface="Consolas"/>
+              </a:rPr>
+              <a:t>                cats.append(c)</a:t>
+            </a:r>
+          </a:p>
+          <a:p>
+            <a:pPr>
+              <a:lnSpc>
+                <a:spcPct val="100000"/>
+              </a:lnSpc>
+              <a:spcBef>
+                <a:spcPts val="0"/>
+              </a:spcBef>
+              <a:spcAft>
+                <a:spcPts val="0"/>
+              </a:spcAft>
+            </a:pPr>
+            <a:r>
+              <a:rPr sz="1200" b="0" i="0">
+                <a:solidFill>
+                  <a:srgbClr val="CDD6F4"/>
+                </a:solidFill>
+                <a:latin typeface="Consolas"/>
+              </a:rPr>
+              <a:t>    return cats</a:t>
+            </a:r>
+          </a:p>
+          <a:p>
+            <a:pPr>
+              <a:lnSpc>
+                <a:spcPct val="100000"/>
+              </a:lnSpc>
+              <a:spcBef>
+                <a:spcPts val="0"/>
+              </a:spcBef>
+              <a:spcAft>
+                <a:spcPts val="0"/>
+              </a:spcAft>
+            </a:pPr>
+            <a:r>
+              <a:rPr sz="1200" b="0" i="0">
+                <a:solidFill>
+                  <a:srgbClr val="CDD6F4"/>
+                </a:solidFill>
+                <a:latin typeface="Consolas"/>
+              </a:rPr>
+              <a:t>    # ... (continues in source)</a:t>
+            </a:r>
+          </a:p>
+        </p:txBody>
+      </p:sp>
+    </p:spTree>
+  </p:cSld>
+  <p:clrMapOvr>
+    <a:masterClrMapping/>
+  </p:clrMapOvr>
+</p:sld>
+</file>
+
+<file path=ppt/slides/slide22.xml><?xml version="1.0" encoding="utf-8"?>
 <p:sld xmlns:a="http://schemas.openxmlformats.org/drawingml/2006/main" xmlns:p="http://schemas.openxmlformats.org/presentationml/2006/main" xmlns:r="http://schemas.openxmlformats.org/officeDocument/2006/relationships">
   <p:cSld>
     <p:spTree>
@@ -12070,7 +13131,7 @@
 </p:sld>
 </file>
 
-<file path=ppt/slides/slide22.xml><?xml version="1.0" encoding="utf-8"?>
+<file path=ppt/slides/slide23.xml><?xml version="1.0" encoding="utf-8"?>
 <p:sld xmlns:a="http://schemas.openxmlformats.org/drawingml/2006/main" xmlns:p="http://schemas.openxmlformats.org/presentationml/2006/main" xmlns:r="http://schemas.openxmlformats.org/officeDocument/2006/relationships">
   <p:cSld>
     <p:spTree>
@@ -12185,8 +13246,8 @@
         </p:nvSpPr>
         <p:spPr>
           <a:xfrm>
-            <a:off x="502920" y="1234440"/>
-            <a:ext cx="11185855" cy="5257800"/>
+            <a:off x="502920" y="1188720"/>
+            <a:ext cx="11185855" cy="5303520"/>
           </a:xfrm>
           <a:prstGeom prst="rect">
             <a:avLst/>
@@ -12201,129 +13262,129 @@
           <a:p>
             <a:pPr>
               <a:spcAft>
-                <a:spcPts val="1100"/>
-              </a:spcAft>
-            </a:pPr>
-            <a:r>
-              <a:rPr sz="1700" b="0" i="0">
+                <a:spcPts val="900"/>
+              </a:spcAft>
+            </a:pPr>
+            <a:r>
+              <a:rPr sz="1600" b="0" i="0">
                 <a:solidFill>
                   <a:srgbClr val="20242B"/>
                 </a:solidFill>
                 <a:latin typeface="Calibri"/>
               </a:rPr>
-              <a:t>•  "Cancel the wireless mouse on ORD-78321" — low-value, unambiguous → cancels directly, refunds to original, no needless confirmation.</a:t>
-            </a:r>
-          </a:p>
-          <a:p>
-            <a:pPr>
-              <a:spcAft>
-                <a:spcPts val="1100"/>
-              </a:spcAft>
-            </a:pPr>
-            <a:r>
-              <a:rPr sz="1700" b="0" i="0">
+              <a:t>•  "Cancel the notebook on ORD-10001" — low-value, unambiguous → cancels directly, refunds to original, no needless confirmation.</a:t>
+            </a:r>
+          </a:p>
+          <a:p>
+            <a:pPr>
+              <a:spcAft>
+                <a:spcPts val="900"/>
+              </a:spcAft>
+            </a:pPr>
+            <a:r>
+              <a:rPr sz="1600" b="0" i="0">
                 <a:solidFill>
                   <a:srgbClr val="20242B"/>
                 </a:solidFill>
                 <a:latin typeface="Calibri"/>
               </a:rPr>
-              <a:t>•  "Cancel the Dell laptop on ORD-78321" — high-value → code forces confirmation; on "yes", over-limit refund escalates instead of paying.</a:t>
-            </a:r>
-          </a:p>
-          <a:p>
-            <a:pPr>
-              <a:spcAft>
-                <a:spcPts val="1100"/>
-              </a:spcAft>
-            </a:pPr>
-            <a:r>
-              <a:rPr sz="1700" b="0" i="0">
+              <a:t>•  "Cancel my Dell laptop on ORD-10001" (₹95,000) → code forces confirmation; on "yes", over-limit refund escalates instead of paying.</a:t>
+            </a:r>
+          </a:p>
+          <a:p>
+            <a:pPr>
+              <a:spcAft>
+                <a:spcPts val="900"/>
+              </a:spcAft>
+            </a:pPr>
+            <a:r>
+              <a:rPr sz="1600" b="0" i="0">
                 <a:solidFill>
                   <a:srgbClr val="20242B"/>
                 </a:solidFill>
                 <a:latin typeface="Calibri"/>
               </a:rPr>
-              <a:t>•  "Refund to my American Express card" — no model call, no action → deterministic supported-methods menu, original first.</a:t>
-            </a:r>
-          </a:p>
-          <a:p>
-            <a:pPr>
-              <a:spcAft>
-                <a:spcPts val="1100"/>
-              </a:spcAft>
-            </a:pPr>
-            <a:r>
-              <a:rPr sz="1700" b="0" i="0">
+              <a:t>•  "Cancel the cotton kurta on ORD-10002" — two active kurtas (blue/green) → asks which one; never guesses.</a:t>
+            </a:r>
+          </a:p>
+          <a:p>
+            <a:pPr>
+              <a:spcAft>
+                <a:spcPts val="900"/>
+              </a:spcAft>
+            </a:pPr>
+            <a:r>
+              <a:rPr sz="1600" b="0" i="0">
                 <a:solidFill>
                   <a:srgbClr val="20242B"/>
                 </a:solidFill>
                 <a:latin typeface="Calibri"/>
               </a:rPr>
-              <a:t>•  "I never placed this order, this is fraud" — instant high-priority escalation, zero autonomous action, model never runs.</a:t>
-            </a:r>
-          </a:p>
-          <a:p>
-            <a:pPr>
-              <a:spcAft>
-                <a:spcPts val="1100"/>
-              </a:spcAft>
-            </a:pPr>
-            <a:r>
-              <a:rPr sz="1700" b="0" i="0">
+              <a:t>•  "Refund to my American Express card" — no model call → deterministic supported-methods menu, original first.</a:t>
+            </a:r>
+          </a:p>
+          <a:p>
+            <a:pPr>
+              <a:spcAft>
+                <a:spcPts val="900"/>
+              </a:spcAft>
+            </a:pPr>
+            <a:r>
+              <a:rPr sz="1600" b="0" i="0">
                 <a:solidFill>
                   <a:srgbClr val="20242B"/>
                 </a:solidFill>
                 <a:latin typeface="Calibri"/>
               </a:rPr>
-              <a:t>•  One message across several orders — completes the valid action AND escalates the over-limit one; narrates both.</a:t>
-            </a:r>
-          </a:p>
-          <a:p>
-            <a:pPr>
-              <a:spcAft>
-                <a:spcPts val="1100"/>
-              </a:spcAft>
-            </a:pPr>
-            <a:r>
-              <a:rPr sz="1700" b="0" i="0">
+              <a:t>•  "My LG OLED TV on ORD-40001 arrived smashed" — instant high-priority escalation, no refund, model barely runs.</a:t>
+            </a:r>
+          </a:p>
+          <a:p>
+            <a:pPr>
+              <a:spcAft>
+                <a:spcPts val="900"/>
+              </a:spcAft>
+            </a:pPr>
+            <a:r>
+              <a:rPr sz="1600" b="0" i="0">
                 <a:solidFill>
                   <a:srgbClr val="20242B"/>
                 </a:solidFill>
                 <a:latin typeface="Calibri"/>
               </a:rPr>
-              <a:t>•  "What is your refund policy?" — trace shows a kb_grounding step and NO planner call; answer quotes real figures (₹25k, 30-day, 5-day SLA).</a:t>
-            </a:r>
-          </a:p>
-          <a:p>
-            <a:pPr>
-              <a:spcAft>
-                <a:spcPts val="1100"/>
-              </a:spcAft>
-            </a:pPr>
-            <a:r>
-              <a:rPr sz="1700" b="0" i="0">
+              <a:t>•  "What's the return window?" for a headphones order vs a saree order → 7 days vs 30 days; same question, category-correct answer.</a:t>
+            </a:r>
+          </a:p>
+          <a:p>
+            <a:pPr>
+              <a:spcAft>
+                <a:spcPts val="900"/>
+              </a:spcAft>
+            </a:pPr>
+            <a:r>
+              <a:rPr sz="1600" b="0" i="0">
                 <a:solidFill>
                   <a:srgbClr val="20242B"/>
                 </a:solidFill>
                 <a:latin typeface="Calibri"/>
               </a:rPr>
+              <a:t>•  "What are your policies on orders I didn't place?" — answered from KB, NO fraud case (a question, not a report).</a:t>
+            </a:r>
+          </a:p>
+          <a:p>
+            <a:pPr>
+              <a:spcAft>
+                <a:spcPts val="900"/>
+              </a:spcAft>
+            </a:pPr>
+            <a:r>
+              <a:rPr sz="1600" b="0" i="0">
+                <a:solidFill>
+                  <a:srgbClr val="20242B"/>
+                </a:solidFill>
+                <a:latin typeface="Calibri"/>
+              </a:rPr>
               <a:t>•  "...my card is 4539 1488 0343 6467" — first trace step is a redact event; raw card appears nowhere in request, reply, or logs.</a:t>
-            </a:r>
-          </a:p>
-          <a:p>
-            <a:pPr>
-              <a:spcAft>
-                <a:spcPts val="1100"/>
-              </a:spcAft>
-            </a:pPr>
-            <a:r>
-              <a:rPr sz="1700" b="1" i="0">
-                <a:solidFill>
-                  <a:srgbClr val="20242B"/>
-                </a:solidFill>
-                <a:latin typeface="Calibri"/>
-              </a:rPr>
-              <a:t>•  Every action ties to a trace ID and a matching audit-log entry — attributable end to end.</a:t>
             </a:r>
           </a:p>
         </p:txBody>
@@ -12336,7 +13397,7 @@
 </p:sld>
 </file>
 
-<file path=ppt/slides/slide23.xml><?xml version="1.0" encoding="utf-8"?>
+<file path=ppt/slides/slide24.xml><?xml version="1.0" encoding="utf-8"?>
 <p:sld xmlns:a="http://schemas.openxmlformats.org/drawingml/2006/main" xmlns:p="http://schemas.openxmlformats.org/presentationml/2006/main" xmlns:r="http://schemas.openxmlformats.org/officeDocument/2006/relationships">
   <p:cSld>
     <p:spTree>
@@ -12634,7 +13695,7 @@
 </p:sld>
 </file>
 
-<file path=ppt/slides/slide24.xml><?xml version="1.0" encoding="utf-8"?>
+<file path=ppt/slides/slide25.xml><?xml version="1.0" encoding="utf-8"?>
 <p:sld xmlns:a="http://schemas.openxmlformats.org/drawingml/2006/main" xmlns:p="http://schemas.openxmlformats.org/presentationml/2006/main" xmlns:r="http://schemas.openxmlformats.org/officeDocument/2006/relationships">
   <p:cSld>
     <p:spTree>
@@ -14480,7 +15541,7 @@
               </a:spcAft>
             </a:pPr>
             <a:r>
-              <a:rPr sz="1100" b="0" i="0">
+              <a:rPr sz="1200" b="0" i="0">
                 <a:solidFill>
                   <a:srgbClr val="CDD6F4"/>
                 </a:solidFill>
@@ -14502,29 +15563,51 @@
               </a:spcAft>
             </a:pPr>
             <a:r>
-              <a:rPr sz="1100" b="0" i="0">
-                <a:solidFill>
-                  <a:srgbClr val="CDD6F4"/>
-                </a:solidFill>
-                <a:latin typeface="Consolas"/>
-              </a:rPr>
-              <a:t>    """Resolve the auto-refund threshold so every enforcement layer agrees.</a:t>
-            </a:r>
-          </a:p>
-          <a:p>
-            <a:pPr>
-              <a:lnSpc>
-                <a:spcPct val="100000"/>
-              </a:lnSpc>
-              <a:spcBef>
-                <a:spcPts val="0"/>
-              </a:spcBef>
-              <a:spcAft>
-                <a:spcPts val="0"/>
-              </a:spcAft>
-            </a:pPr>
-            <a:r>
-              <a:rPr sz="1100" b="0" i="0">
+              <a:rPr sz="1200" b="0" i="0">
+                <a:solidFill>
+                  <a:srgbClr val="CDD6F4"/>
+                </a:solidFill>
+                <a:latin typeface="Consolas"/>
+              </a:rPr>
+              <a:t>    try:</a:t>
+            </a:r>
+          </a:p>
+          <a:p>
+            <a:pPr>
+              <a:lnSpc>
+                <a:spcPct val="100000"/>
+              </a:lnSpc>
+              <a:spcBef>
+                <a:spcPts val="0"/>
+              </a:spcBef>
+              <a:spcAft>
+                <a:spcPts val="0"/>
+              </a:spcAft>
+            </a:pPr>
+            <a:r>
+              <a:rPr sz="1200" b="0" i="0">
+                <a:solidFill>
+                  <a:srgbClr val="CDD6F4"/>
+                </a:solidFill>
+                <a:latin typeface="Consolas"/>
+              </a:rPr>
+              <a:t>        from repositories.payment_repository import PaymentRepository</a:t>
+            </a:r>
+          </a:p>
+          <a:p>
+            <a:pPr>
+              <a:lnSpc>
+                <a:spcPct val="100000"/>
+              </a:lnSpc>
+              <a:spcBef>
+                <a:spcPts val="0"/>
+              </a:spcBef>
+              <a:spcAft>
+                <a:spcPts val="0"/>
+              </a:spcAft>
+            </a:pPr>
+            <a:r>
+              <a:rPr sz="1200" b="0" i="0">
                 <a:solidFill>
                   <a:srgbClr val="CDD6F4"/>
                 </a:solidFill>
@@ -14546,293 +15629,7 @@
               </a:spcAft>
             </a:pPr>
             <a:r>
-              <a:rPr sz="1100" b="0" i="0">
-                <a:solidFill>
-                  <a:srgbClr val="CDD6F4"/>
-                </a:solidFill>
-                <a:latin typeface="Consolas"/>
-              </a:rPr>
-              <a:t>    Precedence (mirrors PaymentTool._enforce_threshold):</a:t>
-            </a:r>
-          </a:p>
-          <a:p>
-            <a:pPr>
-              <a:lnSpc>
-                <a:spcPct val="100000"/>
-              </a:lnSpc>
-              <a:spcBef>
-                <a:spcPts val="0"/>
-              </a:spcBef>
-              <a:spcAft>
-                <a:spcPts val="0"/>
-              </a:spcAft>
-            </a:pPr>
-            <a:r>
-              <a:rPr sz="1100" b="0" i="0">
-                <a:solidFill>
-                  <a:srgbClr val="CDD6F4"/>
-                </a:solidFill>
-                <a:latin typeface="Consolas"/>
-              </a:rPr>
-              <a:t>      1. ``auto_refund_limit_inr`` in payment_config.json — the data the</a:t>
-            </a:r>
-          </a:p>
-          <a:p>
-            <a:pPr>
-              <a:lnSpc>
-                <a:spcPct val="100000"/>
-              </a:lnSpc>
-              <a:spcBef>
-                <a:spcPts val="0"/>
-              </a:spcBef>
-              <a:spcAft>
-                <a:spcPts val="0"/>
-              </a:spcAft>
-            </a:pPr>
-            <a:r>
-              <a:rPr sz="1100" b="0" i="0">
-                <a:solidFill>
-                  <a:srgbClr val="CDD6F4"/>
-                </a:solidFill>
-                <a:latin typeface="Consolas"/>
-              </a:rPr>
-              <a:t>         operator/evaluator supplies. This is what lets the threshold track</a:t>
-            </a:r>
-          </a:p>
-          <a:p>
-            <a:pPr>
-              <a:lnSpc>
-                <a:spcPct val="100000"/>
-              </a:lnSpc>
-              <a:spcBef>
-                <a:spcPts val="0"/>
-              </a:spcBef>
-              <a:spcAft>
-                <a:spcPts val="0"/>
-              </a:spcAft>
-            </a:pPr>
-            <a:r>
-              <a:rPr sz="1100" b="0" i="0">
-                <a:solidFill>
-                  <a:srgbClr val="CDD6F4"/>
-                </a:solidFill>
-                <a:latin typeface="Consolas"/>
-              </a:rPr>
-              <a:t>         the deployed config WITHOUT a code change, so a swapped-in data</a:t>
-            </a:r>
-          </a:p>
-          <a:p>
-            <a:pPr>
-              <a:lnSpc>
-                <a:spcPct val="100000"/>
-              </a:lnSpc>
-              <a:spcBef>
-                <a:spcPts val="0"/>
-              </a:spcBef>
-              <a:spcAft>
-                <a:spcPts val="0"/>
-              </a:spcAft>
-            </a:pPr>
-            <a:r>
-              <a:rPr sz="1100" b="0" i="0">
-                <a:solidFill>
-                  <a:srgbClr val="CDD6F4"/>
-                </a:solidFill>
-                <a:latin typeface="Consolas"/>
-              </a:rPr>
-              <a:t>         folder is honoured by the guardrail and the agent prompt alike.</a:t>
-            </a:r>
-          </a:p>
-          <a:p>
-            <a:pPr>
-              <a:lnSpc>
-                <a:spcPct val="100000"/>
-              </a:lnSpc>
-              <a:spcBef>
-                <a:spcPts val="0"/>
-              </a:spcBef>
-              <a:spcAft>
-                <a:spcPts val="0"/>
-              </a:spcAft>
-            </a:pPr>
-            <a:r>
-              <a:rPr sz="1100" b="0" i="0">
-                <a:solidFill>
-                  <a:srgbClr val="CDD6F4"/>
-                </a:solidFill>
-                <a:latin typeface="Consolas"/>
-              </a:rPr>
-              <a:t>      2. ``AUTO_REFUND_LIMIT_INR`` env var — fallback when config is missing.</a:t>
-            </a:r>
-          </a:p>
-          <a:p>
-            <a:pPr>
-              <a:lnSpc>
-                <a:spcPct val="100000"/>
-              </a:lnSpc>
-              <a:spcBef>
-                <a:spcPts val="0"/>
-              </a:spcBef>
-              <a:spcAft>
-                <a:spcPts val="0"/>
-              </a:spcAft>
-            </a:pPr>
-            <a:r>
-              <a:rPr sz="1100" b="0" i="0">
-                <a:solidFill>
-                  <a:srgbClr val="CDD6F4"/>
-                </a:solidFill>
-                <a:latin typeface="Consolas"/>
-              </a:rPr>
-              <a:t>      3. Rs.25,000 hardcoded safe default.</a:t>
-            </a:r>
-          </a:p>
-          <a:p>
-            <a:pPr>
-              <a:lnSpc>
-                <a:spcPct val="100000"/>
-              </a:lnSpc>
-              <a:spcBef>
-                <a:spcPts val="0"/>
-              </a:spcBef>
-              <a:spcAft>
-                <a:spcPts val="0"/>
-              </a:spcAft>
-            </a:pPr>
-            <a:r>
-              <a:rPr sz="1100" b="0" i="0">
-                <a:solidFill>
-                  <a:srgbClr val="CDD6F4"/>
-                </a:solidFill>
-                <a:latin typeface="Consolas"/>
-              </a:rPr>
-              <a:t> </a:t>
-            </a:r>
-          </a:p>
-          <a:p>
-            <a:pPr>
-              <a:lnSpc>
-                <a:spcPct val="100000"/>
-              </a:lnSpc>
-              <a:spcBef>
-                <a:spcPts val="0"/>
-              </a:spcBef>
-              <a:spcAft>
-                <a:spcPts val="0"/>
-              </a:spcAft>
-            </a:pPr>
-            <a:r>
-              <a:rPr sz="1100" b="0" i="0">
-                <a:solidFill>
-                  <a:srgbClr val="CDD6F4"/>
-                </a:solidFill>
-                <a:latin typeface="Consolas"/>
-              </a:rPr>
-              <a:t>    NEVER change the default without a compliance review.</a:t>
-            </a:r>
-          </a:p>
-          <a:p>
-            <a:pPr>
-              <a:lnSpc>
-                <a:spcPct val="100000"/>
-              </a:lnSpc>
-              <a:spcBef>
-                <a:spcPts val="0"/>
-              </a:spcBef>
-              <a:spcAft>
-                <a:spcPts val="0"/>
-              </a:spcAft>
-            </a:pPr>
-            <a:r>
-              <a:rPr sz="1100" b="0" i="0">
-                <a:solidFill>
-                  <a:srgbClr val="CDD6F4"/>
-                </a:solidFill>
-                <a:latin typeface="Consolas"/>
-              </a:rPr>
-              <a:t>    """</a:t>
-            </a:r>
-          </a:p>
-          <a:p>
-            <a:pPr>
-              <a:lnSpc>
-                <a:spcPct val="100000"/>
-              </a:lnSpc>
-              <a:spcBef>
-                <a:spcPts val="0"/>
-              </a:spcBef>
-              <a:spcAft>
-                <a:spcPts val="0"/>
-              </a:spcAft>
-            </a:pPr>
-            <a:r>
-              <a:rPr sz="1100" b="0" i="0">
-                <a:solidFill>
-                  <a:srgbClr val="CDD6F4"/>
-                </a:solidFill>
-                <a:latin typeface="Consolas"/>
-              </a:rPr>
-              <a:t>    try:</a:t>
-            </a:r>
-          </a:p>
-          <a:p>
-            <a:pPr>
-              <a:lnSpc>
-                <a:spcPct val="100000"/>
-              </a:lnSpc>
-              <a:spcBef>
-                <a:spcPts val="0"/>
-              </a:spcBef>
-              <a:spcAft>
-                <a:spcPts val="0"/>
-              </a:spcAft>
-            </a:pPr>
-            <a:r>
-              <a:rPr sz="1100" b="0" i="0">
-                <a:solidFill>
-                  <a:srgbClr val="CDD6F4"/>
-                </a:solidFill>
-                <a:latin typeface="Consolas"/>
-              </a:rPr>
-              <a:t>        from repositories.payment_repository import PaymentRepository</a:t>
-            </a:r>
-          </a:p>
-          <a:p>
-            <a:pPr>
-              <a:lnSpc>
-                <a:spcPct val="100000"/>
-              </a:lnSpc>
-              <a:spcBef>
-                <a:spcPts val="0"/>
-              </a:spcBef>
-              <a:spcAft>
-                <a:spcPts val="0"/>
-              </a:spcAft>
-            </a:pPr>
-            <a:r>
-              <a:rPr sz="1100" b="0" i="0">
-                <a:solidFill>
-                  <a:srgbClr val="CDD6F4"/>
-                </a:solidFill>
-                <a:latin typeface="Consolas"/>
-              </a:rPr>
-              <a:t> </a:t>
-            </a:r>
-          </a:p>
-          <a:p>
-            <a:pPr>
-              <a:lnSpc>
-                <a:spcPct val="100000"/>
-              </a:lnSpc>
-              <a:spcBef>
-                <a:spcPts val="0"/>
-              </a:spcBef>
-              <a:spcAft>
-                <a:spcPts val="0"/>
-              </a:spcAft>
-            </a:pPr>
-            <a:r>
-              <a:rPr sz="1100" b="0" i="0">
+              <a:rPr sz="1200" b="0" i="0">
                 <a:solidFill>
                   <a:srgbClr val="CDD6F4"/>
                 </a:solidFill>
@@ -14854,7 +15651,7 @@
               </a:spcAft>
             </a:pPr>
             <a:r>
-              <a:rPr sz="1100" b="0" i="0">
+              <a:rPr sz="1200" b="0" i="0">
                 <a:solidFill>
                   <a:srgbClr val="CDD6F4"/>
                 </a:solidFill>
@@ -14876,7 +15673,7 @@
               </a:spcAft>
             </a:pPr>
             <a:r>
-              <a:rPr sz="1100" b="0" i="0">
+              <a:rPr sz="1200" b="0" i="0">
                 <a:solidFill>
                   <a:srgbClr val="CDD6F4"/>
                 </a:solidFill>
@@ -14898,29 +15695,29 @@
               </a:spcAft>
             </a:pPr>
             <a:r>
-              <a:rPr sz="1100" b="0" i="0">
-                <a:solidFill>
-                  <a:srgbClr val="CDD6F4"/>
-                </a:solidFill>
-                <a:latin typeface="Consolas"/>
-              </a:rPr>
-              <a:t>    except Exception as exc:  # pragma: no cover - defensive</a:t>
-            </a:r>
-          </a:p>
-          <a:p>
-            <a:pPr>
-              <a:lnSpc>
-                <a:spcPct val="100000"/>
-              </a:lnSpc>
-              <a:spcBef>
-                <a:spcPts val="0"/>
-              </a:spcBef>
-              <a:spcAft>
-                <a:spcPts val="0"/>
-              </a:spcAft>
-            </a:pPr>
-            <a:r>
-              <a:rPr sz="1100" b="0" i="0">
+              <a:rPr sz="1200" b="0" i="0">
+                <a:solidFill>
+                  <a:srgbClr val="CDD6F4"/>
+                </a:solidFill>
+                <a:latin typeface="Consolas"/>
+              </a:rPr>
+              <a:t>    except Exception as exc:</a:t>
+            </a:r>
+          </a:p>
+          <a:p>
+            <a:pPr>
+              <a:lnSpc>
+                <a:spcPct val="100000"/>
+              </a:lnSpc>
+              <a:spcBef>
+                <a:spcPts val="0"/>
+              </a:spcBef>
+              <a:spcAft>
+                <a:spcPts val="0"/>
+              </a:spcAft>
+            </a:pPr>
+            <a:r>
+              <a:rPr sz="1200" b="0" i="0">
                 <a:solidFill>
                   <a:srgbClr val="CDD6F4"/>
                 </a:solidFill>
@@ -14942,7 +15739,7 @@
               </a:spcAft>
             </a:pPr>
             <a:r>
-              <a:rPr sz="1100" b="0" i="0">
+              <a:rPr sz="1200" b="0" i="0">
                 <a:solidFill>
                   <a:srgbClr val="CDD6F4"/>
                 </a:solidFill>
@@ -15480,7 +16277,7 @@
               </a:spcAft>
             </a:pPr>
             <a:r>
-              <a:rPr sz="1200" b="0" i="0">
+              <a:rPr sz="1000" b="0" i="0">
                 <a:solidFill>
                   <a:srgbClr val="CDD6F4"/>
                 </a:solidFill>
@@ -15502,7 +16299,7 @@
               </a:spcAft>
             </a:pPr>
             <a:r>
-              <a:rPr sz="1200" b="0" i="0">
+              <a:rPr sz="1000" b="0" i="0">
                 <a:solidFill>
                   <a:srgbClr val="CDD6F4"/>
                 </a:solidFill>
@@ -15524,7 +16321,7 @@
               </a:spcAft>
             </a:pPr>
             <a:r>
-              <a:rPr sz="1200" b="0" i="0">
+              <a:rPr sz="1000" b="0" i="0">
                 <a:solidFill>
                   <a:srgbClr val="CDD6F4"/>
                 </a:solidFill>
@@ -15546,7 +16343,7 @@
               </a:spcAft>
             </a:pPr>
             <a:r>
-              <a:rPr sz="1200" b="0" i="0">
+              <a:rPr sz="1000" b="0" i="0">
                 <a:solidFill>
                   <a:srgbClr val="CDD6F4"/>
                 </a:solidFill>
@@ -15568,13 +16365,585 @@
               </a:spcAft>
             </a:pPr>
             <a:r>
-              <a:rPr sz="1200" b="0" i="0">
+              <a:rPr sz="1000" b="0" i="0">
                 <a:solidFill>
                   <a:srgbClr val="CDD6F4"/>
                 </a:solidFill>
                 <a:latin typeface="Consolas"/>
               </a:rPr>
               <a:t>        **_,</a:t>
+            </a:r>
+          </a:p>
+          <a:p>
+            <a:pPr>
+              <a:lnSpc>
+                <a:spcPct val="100000"/>
+              </a:lnSpc>
+              <a:spcBef>
+                <a:spcPts val="0"/>
+              </a:spcBef>
+              <a:spcAft>
+                <a:spcPts val="0"/>
+              </a:spcAft>
+            </a:pPr>
+            <a:r>
+              <a:rPr sz="1000" b="0" i="0">
+                <a:solidFill>
+                  <a:srgbClr val="CDD6F4"/>
+                </a:solidFill>
+                <a:latin typeface="Consolas"/>
+              </a:rPr>
+              <a:t>    ) -&gt; GuardrailVerdict:</a:t>
+            </a:r>
+          </a:p>
+          <a:p>
+            <a:pPr>
+              <a:lnSpc>
+                <a:spcPct val="100000"/>
+              </a:lnSpc>
+              <a:spcBef>
+                <a:spcPts val="0"/>
+              </a:spcBef>
+              <a:spcAft>
+                <a:spcPts val="0"/>
+              </a:spcAft>
+            </a:pPr>
+            <a:r>
+              <a:rPr sz="1000" b="0" i="0">
+                <a:solidFill>
+                  <a:srgbClr val="CDD6F4"/>
+                </a:solidFill>
+                <a:latin typeface="Consolas"/>
+              </a:rPr>
+              <a:t>        # Strict (currency-marked) amounts plus bare amounts anchored to a refund</a:t>
+            </a:r>
+          </a:p>
+          <a:p>
+            <a:pPr>
+              <a:lnSpc>
+                <a:spcPct val="100000"/>
+              </a:lnSpc>
+              <a:spcBef>
+                <a:spcPts val="0"/>
+              </a:spcBef>
+              <a:spcAft>
+                <a:spcPts val="0"/>
+              </a:spcAft>
+            </a:pPr>
+            <a:r>
+              <a:rPr sz="1000" b="0" i="0">
+                <a:solidFill>
+                  <a:srgbClr val="CDD6F4"/>
+                </a:solidFill>
+                <a:latin typeface="Consolas"/>
+              </a:rPr>
+              <a:t>        # verb, so "refund 50000" (no ₹/Rs) is caught and fast-escalated pre-LLM.</a:t>
+            </a:r>
+          </a:p>
+          <a:p>
+            <a:pPr>
+              <a:lnSpc>
+                <a:spcPct val="100000"/>
+              </a:lnSpc>
+              <a:spcBef>
+                <a:spcPts val="0"/>
+              </a:spcBef>
+              <a:spcAft>
+                <a:spcPts val="0"/>
+              </a:spcAft>
+            </a:pPr>
+            <a:r>
+              <a:rPr sz="1000" b="0" i="0">
+                <a:solidFill>
+                  <a:srgbClr val="CDD6F4"/>
+                </a:solidFill>
+                <a:latin typeface="Consolas"/>
+              </a:rPr>
+              <a:t>        amounts = _extract_amounts(message) + _extract_refund_context_amounts(message)</a:t>
+            </a:r>
+          </a:p>
+          <a:p>
+            <a:pPr>
+              <a:lnSpc>
+                <a:spcPct val="100000"/>
+              </a:lnSpc>
+              <a:spcBef>
+                <a:spcPts val="0"/>
+              </a:spcBef>
+              <a:spcAft>
+                <a:spcPts val="0"/>
+              </a:spcAft>
+            </a:pPr>
+            <a:r>
+              <a:rPr sz="1000" b="0" i="0">
+                <a:solidFill>
+                  <a:srgbClr val="CDD6F4"/>
+                </a:solidFill>
+                <a:latin typeface="Consolas"/>
+              </a:rPr>
+              <a:t>        refund_keywords = re.search(</a:t>
+            </a:r>
+          </a:p>
+          <a:p>
+            <a:pPr>
+              <a:lnSpc>
+                <a:spcPct val="100000"/>
+              </a:lnSpc>
+              <a:spcBef>
+                <a:spcPts val="0"/>
+              </a:spcBef>
+              <a:spcAft>
+                <a:spcPts val="0"/>
+              </a:spcAft>
+            </a:pPr>
+            <a:r>
+              <a:rPr sz="1000" b="0" i="0">
+                <a:solidFill>
+                  <a:srgbClr val="CDD6F4"/>
+                </a:solidFill>
+                <a:latin typeface="Consolas"/>
+              </a:rPr>
+              <a:t>            r"\b(refund|return|money back|reimburs)\b",</a:t>
+            </a:r>
+          </a:p>
+          <a:p>
+            <a:pPr>
+              <a:lnSpc>
+                <a:spcPct val="100000"/>
+              </a:lnSpc>
+              <a:spcBef>
+                <a:spcPts val="0"/>
+              </a:spcBef>
+              <a:spcAft>
+                <a:spcPts val="0"/>
+              </a:spcAft>
+            </a:pPr>
+            <a:r>
+              <a:rPr sz="1000" b="0" i="0">
+                <a:solidFill>
+                  <a:srgbClr val="CDD6F4"/>
+                </a:solidFill>
+                <a:latin typeface="Consolas"/>
+              </a:rPr>
+              <a:t>            message,</a:t>
+            </a:r>
+          </a:p>
+          <a:p>
+            <a:pPr>
+              <a:lnSpc>
+                <a:spcPct val="100000"/>
+              </a:lnSpc>
+              <a:spcBef>
+                <a:spcPts val="0"/>
+              </a:spcBef>
+              <a:spcAft>
+                <a:spcPts val="0"/>
+              </a:spcAft>
+            </a:pPr>
+            <a:r>
+              <a:rPr sz="1000" b="0" i="0">
+                <a:solidFill>
+                  <a:srgbClr val="CDD6F4"/>
+                </a:solidFill>
+                <a:latin typeface="Consolas"/>
+              </a:rPr>
+              <a:t>            re.IGNORECASE,</a:t>
+            </a:r>
+          </a:p>
+          <a:p>
+            <a:pPr>
+              <a:lnSpc>
+                <a:spcPct val="100000"/>
+              </a:lnSpc>
+              <a:spcBef>
+                <a:spcPts val="0"/>
+              </a:spcBef>
+              <a:spcAft>
+                <a:spcPts val="0"/>
+              </a:spcAft>
+            </a:pPr>
+            <a:r>
+              <a:rPr sz="1000" b="0" i="0">
+                <a:solidFill>
+                  <a:srgbClr val="CDD6F4"/>
+                </a:solidFill>
+                <a:latin typeface="Consolas"/>
+              </a:rPr>
+              <a:t>        )</a:t>
+            </a:r>
+          </a:p>
+          <a:p>
+            <a:pPr>
+              <a:lnSpc>
+                <a:spcPct val="100000"/>
+              </a:lnSpc>
+              <a:spcBef>
+                <a:spcPts val="0"/>
+              </a:spcBef>
+              <a:spcAft>
+                <a:spcPts val="0"/>
+              </a:spcAft>
+            </a:pPr>
+            <a:r>
+              <a:rPr sz="1000" b="0" i="0">
+                <a:solidFill>
+                  <a:srgbClr val="CDD6F4"/>
+                </a:solidFill>
+                <a:latin typeface="Consolas"/>
+              </a:rPr>
+              <a:t> </a:t>
+            </a:r>
+          </a:p>
+          <a:p>
+            <a:pPr>
+              <a:lnSpc>
+                <a:spcPct val="100000"/>
+              </a:lnSpc>
+              <a:spcBef>
+                <a:spcPts val="0"/>
+              </a:spcBef>
+              <a:spcAft>
+                <a:spcPts val="0"/>
+              </a:spcAft>
+            </a:pPr>
+            <a:r>
+              <a:rPr sz="1000" b="0" i="0">
+                <a:solidFill>
+                  <a:srgbClr val="CDD6F4"/>
+                </a:solidFill>
+                <a:latin typeface="Consolas"/>
+              </a:rPr>
+              <a:t>        if not refund_keywords or not amounts:</a:t>
+            </a:r>
+          </a:p>
+          <a:p>
+            <a:pPr>
+              <a:lnSpc>
+                <a:spcPct val="100000"/>
+              </a:lnSpc>
+              <a:spcBef>
+                <a:spcPts val="0"/>
+              </a:spcBef>
+              <a:spcAft>
+                <a:spcPts val="0"/>
+              </a:spcAft>
+            </a:pPr>
+            <a:r>
+              <a:rPr sz="1000" b="0" i="0">
+                <a:solidFill>
+                  <a:srgbClr val="CDD6F4"/>
+                </a:solidFill>
+                <a:latin typeface="Consolas"/>
+              </a:rPr>
+              <a:t>            return GuardrailVerdict.allow()</a:t>
+            </a:r>
+          </a:p>
+          <a:p>
+            <a:pPr>
+              <a:lnSpc>
+                <a:spcPct val="100000"/>
+              </a:lnSpc>
+              <a:spcBef>
+                <a:spcPts val="0"/>
+              </a:spcBef>
+              <a:spcAft>
+                <a:spcPts val="0"/>
+              </a:spcAft>
+            </a:pPr>
+            <a:r>
+              <a:rPr sz="1000" b="0" i="0">
+                <a:solidFill>
+                  <a:srgbClr val="CDD6F4"/>
+                </a:solidFill>
+                <a:latin typeface="Consolas"/>
+              </a:rPr>
+              <a:t> </a:t>
+            </a:r>
+          </a:p>
+          <a:p>
+            <a:pPr>
+              <a:lnSpc>
+                <a:spcPct val="100000"/>
+              </a:lnSpc>
+              <a:spcBef>
+                <a:spcPts val="0"/>
+              </a:spcBef>
+              <a:spcAft>
+                <a:spcPts val="0"/>
+              </a:spcAft>
+            </a:pPr>
+            <a:r>
+              <a:rPr sz="1000" b="0" i="0">
+                <a:solidFill>
+                  <a:srgbClr val="CDD6F4"/>
+                </a:solidFill>
+                <a:latin typeface="Consolas"/>
+              </a:rPr>
+              <a:t>        over_threshold = [a for a in amounts if a &gt; AUTO_REFUND_LIMIT_INR]</a:t>
+            </a:r>
+          </a:p>
+          <a:p>
+            <a:pPr>
+              <a:lnSpc>
+                <a:spcPct val="100000"/>
+              </a:lnSpc>
+              <a:spcBef>
+                <a:spcPts val="0"/>
+              </a:spcBef>
+              <a:spcAft>
+                <a:spcPts val="0"/>
+              </a:spcAft>
+            </a:pPr>
+            <a:r>
+              <a:rPr sz="1000" b="0" i="0">
+                <a:solidFill>
+                  <a:srgbClr val="CDD6F4"/>
+                </a:solidFill>
+                <a:latin typeface="Consolas"/>
+              </a:rPr>
+              <a:t>        if not over_threshold:</a:t>
+            </a:r>
+          </a:p>
+          <a:p>
+            <a:pPr>
+              <a:lnSpc>
+                <a:spcPct val="100000"/>
+              </a:lnSpc>
+              <a:spcBef>
+                <a:spcPts val="0"/>
+              </a:spcBef>
+              <a:spcAft>
+                <a:spcPts val="0"/>
+              </a:spcAft>
+            </a:pPr>
+            <a:r>
+              <a:rPr sz="1000" b="0" i="0">
+                <a:solidFill>
+                  <a:srgbClr val="CDD6F4"/>
+                </a:solidFill>
+                <a:latin typeface="Consolas"/>
+              </a:rPr>
+              <a:t>            return GuardrailVerdict.allow()</a:t>
+            </a:r>
+          </a:p>
+          <a:p>
+            <a:pPr>
+              <a:lnSpc>
+                <a:spcPct val="100000"/>
+              </a:lnSpc>
+              <a:spcBef>
+                <a:spcPts val="0"/>
+              </a:spcBef>
+              <a:spcAft>
+                <a:spcPts val="0"/>
+              </a:spcAft>
+            </a:pPr>
+            <a:r>
+              <a:rPr sz="1000" b="0" i="0">
+                <a:solidFill>
+                  <a:srgbClr val="CDD6F4"/>
+                </a:solidFill>
+                <a:latin typeface="Consolas"/>
+              </a:rPr>
+              <a:t> </a:t>
+            </a:r>
+          </a:p>
+          <a:p>
+            <a:pPr>
+              <a:lnSpc>
+                <a:spcPct val="100000"/>
+              </a:lnSpc>
+              <a:spcBef>
+                <a:spcPts val="0"/>
+              </a:spcBef>
+              <a:spcAft>
+                <a:spcPts val="0"/>
+              </a:spcAft>
+            </a:pPr>
+            <a:r>
+              <a:rPr sz="1000" b="0" i="0">
+                <a:solidFill>
+                  <a:srgbClr val="CDD6F4"/>
+                </a:solidFill>
+                <a:latin typeface="Consolas"/>
+              </a:rPr>
+              <a:t>        max_amount = max(over_threshold)</a:t>
+            </a:r>
+          </a:p>
+          <a:p>
+            <a:pPr>
+              <a:lnSpc>
+                <a:spcPct val="100000"/>
+              </a:lnSpc>
+              <a:spcBef>
+                <a:spcPts val="0"/>
+              </a:spcBef>
+              <a:spcAft>
+                <a:spcPts val="0"/>
+              </a:spcAft>
+            </a:pPr>
+            <a:r>
+              <a:rPr sz="1000" b="0" i="0">
+                <a:solidFill>
+                  <a:srgbClr val="CDD6F4"/>
+                </a:solidFill>
+                <a:latin typeface="Consolas"/>
+              </a:rPr>
+              <a:t>        return GuardrailVerdict.block(</a:t>
+            </a:r>
+          </a:p>
+          <a:p>
+            <a:pPr>
+              <a:lnSpc>
+                <a:spcPct val="100000"/>
+              </a:lnSpc>
+              <a:spcBef>
+                <a:spcPts val="0"/>
+              </a:spcBef>
+              <a:spcAft>
+                <a:spcPts val="0"/>
+              </a:spcAft>
+            </a:pPr>
+            <a:r>
+              <a:rPr sz="1000" b="0" i="0">
+                <a:solidFill>
+                  <a:srgbClr val="CDD6F4"/>
+                </a:solidFill>
+                <a:latin typeface="Consolas"/>
+              </a:rPr>
+              <a:t>            rule_id="GR-001",</a:t>
+            </a:r>
+          </a:p>
+          <a:p>
+            <a:pPr>
+              <a:lnSpc>
+                <a:spcPct val="100000"/>
+              </a:lnSpc>
+              <a:spcBef>
+                <a:spcPts val="0"/>
+              </a:spcBef>
+              <a:spcAft>
+                <a:spcPts val="0"/>
+              </a:spcAft>
+            </a:pPr>
+            <a:r>
+              <a:rPr sz="1000" b="0" i="0">
+                <a:solidFill>
+                  <a:srgbClr val="CDD6F4"/>
+                </a:solidFill>
+                <a:latin typeface="Consolas"/>
+              </a:rPr>
+              <a:t>            reason=(</a:t>
+            </a:r>
+          </a:p>
+          <a:p>
+            <a:pPr>
+              <a:lnSpc>
+                <a:spcPct val="100000"/>
+              </a:lnSpc>
+              <a:spcBef>
+                <a:spcPts val="0"/>
+              </a:spcBef>
+              <a:spcAft>
+                <a:spcPts val="0"/>
+              </a:spcAft>
+            </a:pPr>
+            <a:r>
+              <a:rPr sz="1000" b="0" i="0">
+                <a:solidFill>
+                  <a:srgbClr val="CDD6F4"/>
+                </a:solidFill>
+                <a:latin typeface="Consolas"/>
+              </a:rPr>
+              <a:t>                f"Refund amount ₹{max_amount:,.2f} exceeds auto-refund "</a:t>
+            </a:r>
+          </a:p>
+          <a:p>
+            <a:pPr>
+              <a:lnSpc>
+                <a:spcPct val="100000"/>
+              </a:lnSpc>
+              <a:spcBef>
+                <a:spcPts val="0"/>
+              </a:spcBef>
+              <a:spcAft>
+                <a:spcPts val="0"/>
+              </a:spcAft>
+            </a:pPr>
+            <a:r>
+              <a:rPr sz="1000" b="0" i="0">
+                <a:solidFill>
+                  <a:srgbClr val="CDD6F4"/>
+                </a:solidFill>
+                <a:latin typeface="Consolas"/>
+              </a:rPr>
+              <a:t>                f"limit of ₹{AUTO_REFUND_LIMIT_INR:,.0f}. Escalation required."</a:t>
+            </a:r>
+          </a:p>
+          <a:p>
+            <a:pPr>
+              <a:lnSpc>
+                <a:spcPct val="100000"/>
+              </a:lnSpc>
+              <a:spcBef>
+                <a:spcPts val="0"/>
+              </a:spcBef>
+              <a:spcAft>
+                <a:spcPts val="0"/>
+              </a:spcAft>
+            </a:pPr>
+            <a:r>
+              <a:rPr sz="1000" b="0" i="0">
+                <a:solidFill>
+                  <a:srgbClr val="CDD6F4"/>
+                </a:solidFill>
+                <a:latin typeface="Consolas"/>
+              </a:rPr>
+              <a:t>            ),</a:t>
+            </a:r>
+          </a:p>
+          <a:p>
+            <a:pPr>
+              <a:lnSpc>
+                <a:spcPct val="100000"/>
+              </a:lnSpc>
+              <a:spcBef>
+                <a:spcPts val="0"/>
+              </a:spcBef>
+              <a:spcAft>
+                <a:spcPts val="0"/>
+              </a:spcAft>
+            </a:pPr>
+            <a:r>
+              <a:rPr sz="1000" b="0" i="0">
+                <a:solidFill>
+                  <a:srgbClr val="CDD6F4"/>
+                </a:solidFill>
+                <a:latin typeface="Consolas"/>
+              </a:rPr>
+              <a:t>            user_message=(</a:t>
+            </a:r>
+          </a:p>
+          <a:p>
+            <a:pPr>
+              <a:lnSpc>
+                <a:spcPct val="100000"/>
+              </a:lnSpc>
+              <a:spcBef>
+                <a:spcPts val="0"/>
+              </a:spcBef>
+              <a:spcAft>
+                <a:spcPts val="0"/>
+              </a:spcAft>
+            </a:pPr>
+            <a:r>
+              <a:rPr sz="1000" b="0" i="0">
+                <a:solidFill>
+                  <a:srgbClr val="CDD6F4"/>
+                </a:solidFill>
+                <a:latin typeface="Consolas"/>
+              </a:rPr>
+              <a:t>            # ... (continues in source)</a:t>
             </a:r>
           </a:p>
         </p:txBody>
@@ -16366,7 +17735,7 @@
               </a:spcAft>
             </a:pPr>
             <a:r>
-              <a:rPr sz="1200" b="0" i="0">
+              <a:rPr sz="1000" b="0" i="0">
                 <a:solidFill>
                   <a:srgbClr val="CDD6F4"/>
                 </a:solidFill>
@@ -16388,7 +17757,7 @@
               </a:spcAft>
             </a:pPr>
             <a:r>
-              <a:rPr sz="1200" b="0" i="0">
+              <a:rPr sz="1000" b="0" i="0">
                 <a:solidFill>
                   <a:srgbClr val="CDD6F4"/>
                 </a:solidFill>
@@ -16410,13 +17779,585 @@
               </a:spcAft>
             </a:pPr>
             <a:r>
-              <a:rPr sz="1200" b="0" i="0">
+              <a:rPr sz="1000" b="0" i="0">
                 <a:solidFill>
                   <a:srgbClr val="CDD6F4"/>
                 </a:solidFill>
                 <a:latin typeface="Consolas"/>
               </a:rPr>
               <a:t>        execution_summary: list[dict],</a:t>
+            </a:r>
+          </a:p>
+          <a:p>
+            <a:pPr>
+              <a:lnSpc>
+                <a:spcPct val="100000"/>
+              </a:lnSpc>
+              <a:spcBef>
+                <a:spcPts val="0"/>
+              </a:spcBef>
+              <a:spcAft>
+                <a:spcPts val="0"/>
+              </a:spcAft>
+            </a:pPr>
+            <a:r>
+              <a:rPr sz="1000" b="0" i="0">
+                <a:solidFill>
+                  <a:srgbClr val="CDD6F4"/>
+                </a:solidFill>
+                <a:latin typeface="Consolas"/>
+              </a:rPr>
+              <a:t>    ) -&gt; GuardrailVerdict:</a:t>
+            </a:r>
+          </a:p>
+          <a:p>
+            <a:pPr>
+              <a:lnSpc>
+                <a:spcPct val="100000"/>
+              </a:lnSpc>
+              <a:spcBef>
+                <a:spcPts val="0"/>
+              </a:spcBef>
+              <a:spcAft>
+                <a:spcPts val="0"/>
+              </a:spcAft>
+            </a:pPr>
+            <a:r>
+              <a:rPr sz="1000" b="0" i="0">
+                <a:solidFill>
+                  <a:srgbClr val="CDD6F4"/>
+                </a:solidFill>
+                <a:latin typeface="Consolas"/>
+              </a:rPr>
+              <a:t>        for e in execution_summary:</a:t>
+            </a:r>
+          </a:p>
+          <a:p>
+            <a:pPr>
+              <a:lnSpc>
+                <a:spcPct val="100000"/>
+              </a:lnSpc>
+              <a:spcBef>
+                <a:spcPts val="0"/>
+              </a:spcBef>
+              <a:spcAft>
+                <a:spcPts val="0"/>
+              </a:spcAft>
+            </a:pPr>
+            <a:r>
+              <a:rPr sz="1000" b="0" i="0">
+                <a:solidFill>
+                  <a:srgbClr val="CDD6F4"/>
+                </a:solidFill>
+                <a:latin typeface="Consolas"/>
+              </a:rPr>
+              <a:t>            if not e.get("success") or e.get("tool") not in {"process_refund", "cancel_item"}:</a:t>
+            </a:r>
+          </a:p>
+          <a:p>
+            <a:pPr>
+              <a:lnSpc>
+                <a:spcPct val="100000"/>
+              </a:lnSpc>
+              <a:spcBef>
+                <a:spcPts val="0"/>
+              </a:spcBef>
+              <a:spcAft>
+                <a:spcPts val="0"/>
+              </a:spcAft>
+            </a:pPr>
+            <a:r>
+              <a:rPr sz="1000" b="0" i="0">
+                <a:solidFill>
+                  <a:srgbClr val="CDD6F4"/>
+                </a:solidFill>
+                <a:latin typeface="Consolas"/>
+              </a:rPr>
+              <a:t>                continue</a:t>
+            </a:r>
+          </a:p>
+          <a:p>
+            <a:pPr>
+              <a:lnSpc>
+                <a:spcPct val="100000"/>
+              </a:lnSpc>
+              <a:spcBef>
+                <a:spcPts val="0"/>
+              </a:spcBef>
+              <a:spcAft>
+                <a:spcPts val="0"/>
+              </a:spcAft>
+            </a:pPr>
+            <a:r>
+              <a:rPr sz="1000" b="0" i="0">
+                <a:solidFill>
+                  <a:srgbClr val="CDD6F4"/>
+                </a:solidFill>
+                <a:latin typeface="Consolas"/>
+              </a:rPr>
+              <a:t>            refund = (e.get("data") or {}).get("refund")</a:t>
+            </a:r>
+          </a:p>
+          <a:p>
+            <a:pPr>
+              <a:lnSpc>
+                <a:spcPct val="100000"/>
+              </a:lnSpc>
+              <a:spcBef>
+                <a:spcPts val="0"/>
+              </a:spcBef>
+              <a:spcAft>
+                <a:spcPts val="0"/>
+              </a:spcAft>
+            </a:pPr>
+            <a:r>
+              <a:rPr sz="1000" b="0" i="0">
+                <a:solidFill>
+                  <a:srgbClr val="CDD6F4"/>
+                </a:solidFill>
+                <a:latin typeface="Consolas"/>
+              </a:rPr>
+              <a:t>            if not isinstance(refund, dict):</a:t>
+            </a:r>
+          </a:p>
+          <a:p>
+            <a:pPr>
+              <a:lnSpc>
+                <a:spcPct val="100000"/>
+              </a:lnSpc>
+              <a:spcBef>
+                <a:spcPts val="0"/>
+              </a:spcBef>
+              <a:spcAft>
+                <a:spcPts val="0"/>
+              </a:spcAft>
+            </a:pPr>
+            <a:r>
+              <a:rPr sz="1000" b="0" i="0">
+                <a:solidFill>
+                  <a:srgbClr val="CDD6F4"/>
+                </a:solidFill>
+                <a:latin typeface="Consolas"/>
+              </a:rPr>
+              <a:t>                continue</a:t>
+            </a:r>
+          </a:p>
+          <a:p>
+            <a:pPr>
+              <a:lnSpc>
+                <a:spcPct val="100000"/>
+              </a:lnSpc>
+              <a:spcBef>
+                <a:spcPts val="0"/>
+              </a:spcBef>
+              <a:spcAft>
+                <a:spcPts val="0"/>
+              </a:spcAft>
+            </a:pPr>
+            <a:r>
+              <a:rPr sz="1000" b="0" i="0">
+                <a:solidFill>
+                  <a:srgbClr val="CDD6F4"/>
+                </a:solidFill>
+                <a:latin typeface="Consolas"/>
+              </a:rPr>
+              <a:t>            try:</a:t>
+            </a:r>
+          </a:p>
+          <a:p>
+            <a:pPr>
+              <a:lnSpc>
+                <a:spcPct val="100000"/>
+              </a:lnSpc>
+              <a:spcBef>
+                <a:spcPts val="0"/>
+              </a:spcBef>
+              <a:spcAft>
+                <a:spcPts val="0"/>
+              </a:spcAft>
+            </a:pPr>
+            <a:r>
+              <a:rPr sz="1000" b="0" i="0">
+                <a:solidFill>
+                  <a:srgbClr val="CDD6F4"/>
+                </a:solidFill>
+                <a:latin typeface="Consolas"/>
+              </a:rPr>
+              <a:t>                amount = float(refund.get("amount_inr", 0) or 0)</a:t>
+            </a:r>
+          </a:p>
+          <a:p>
+            <a:pPr>
+              <a:lnSpc>
+                <a:spcPct val="100000"/>
+              </a:lnSpc>
+              <a:spcBef>
+                <a:spcPts val="0"/>
+              </a:spcBef>
+              <a:spcAft>
+                <a:spcPts val="0"/>
+              </a:spcAft>
+            </a:pPr>
+            <a:r>
+              <a:rPr sz="1000" b="0" i="0">
+                <a:solidFill>
+                  <a:srgbClr val="CDD6F4"/>
+                </a:solidFill>
+                <a:latin typeface="Consolas"/>
+              </a:rPr>
+              <a:t>            except (TypeError, ValueError):</a:t>
+            </a:r>
+          </a:p>
+          <a:p>
+            <a:pPr>
+              <a:lnSpc>
+                <a:spcPct val="100000"/>
+              </a:lnSpc>
+              <a:spcBef>
+                <a:spcPts val="0"/>
+              </a:spcBef>
+              <a:spcAft>
+                <a:spcPts val="0"/>
+              </a:spcAft>
+            </a:pPr>
+            <a:r>
+              <a:rPr sz="1000" b="0" i="0">
+                <a:solidFill>
+                  <a:srgbClr val="CDD6F4"/>
+                </a:solidFill>
+                <a:latin typeface="Consolas"/>
+              </a:rPr>
+              <a:t>                continue</a:t>
+            </a:r>
+          </a:p>
+          <a:p>
+            <a:pPr>
+              <a:lnSpc>
+                <a:spcPct val="100000"/>
+              </a:lnSpc>
+              <a:spcBef>
+                <a:spcPts val="0"/>
+              </a:spcBef>
+              <a:spcAft>
+                <a:spcPts val="0"/>
+              </a:spcAft>
+            </a:pPr>
+            <a:r>
+              <a:rPr sz="1000" b="0" i="0">
+                <a:solidFill>
+                  <a:srgbClr val="CDD6F4"/>
+                </a:solidFill>
+                <a:latin typeface="Consolas"/>
+              </a:rPr>
+              <a:t>            if amount &gt; AUTO_REFUND_LIMIT_INR:</a:t>
+            </a:r>
+          </a:p>
+          <a:p>
+            <a:pPr>
+              <a:lnSpc>
+                <a:spcPct val="100000"/>
+              </a:lnSpc>
+              <a:spcBef>
+                <a:spcPts val="0"/>
+              </a:spcBef>
+              <a:spcAft>
+                <a:spcPts val="0"/>
+              </a:spcAft>
+            </a:pPr>
+            <a:r>
+              <a:rPr sz="1000" b="0" i="0">
+                <a:solidFill>
+                  <a:srgbClr val="CDD6F4"/>
+                </a:solidFill>
+                <a:latin typeface="Consolas"/>
+              </a:rPr>
+              <a:t>                return GuardrailVerdict.block(</a:t>
+            </a:r>
+          </a:p>
+          <a:p>
+            <a:pPr>
+              <a:lnSpc>
+                <a:spcPct val="100000"/>
+              </a:lnSpc>
+              <a:spcBef>
+                <a:spcPts val="0"/>
+              </a:spcBef>
+              <a:spcAft>
+                <a:spcPts val="0"/>
+              </a:spcAft>
+            </a:pPr>
+            <a:r>
+              <a:rPr sz="1000" b="0" i="0">
+                <a:solidFill>
+                  <a:srgbClr val="CDD6F4"/>
+                </a:solidFill>
+                <a:latin typeface="Consolas"/>
+              </a:rPr>
+              <a:t>                    rule_id="GR-004",</a:t>
+            </a:r>
+          </a:p>
+          <a:p>
+            <a:pPr>
+              <a:lnSpc>
+                <a:spcPct val="100000"/>
+              </a:lnSpc>
+              <a:spcBef>
+                <a:spcPts val="0"/>
+              </a:spcBef>
+              <a:spcAft>
+                <a:spcPts val="0"/>
+              </a:spcAft>
+            </a:pPr>
+            <a:r>
+              <a:rPr sz="1000" b="0" i="0">
+                <a:solidFill>
+                  <a:srgbClr val="CDD6F4"/>
+                </a:solidFill>
+                <a:latin typeface="Consolas"/>
+              </a:rPr>
+              <a:t>                    reason=(</a:t>
+            </a:r>
+          </a:p>
+          <a:p>
+            <a:pPr>
+              <a:lnSpc>
+                <a:spcPct val="100000"/>
+              </a:lnSpc>
+              <a:spcBef>
+                <a:spcPts val="0"/>
+              </a:spcBef>
+              <a:spcAft>
+                <a:spcPts val="0"/>
+              </a:spcAft>
+            </a:pPr>
+            <a:r>
+              <a:rPr sz="1000" b="0" i="0">
+                <a:solidFill>
+                  <a:srgbClr val="CDD6F4"/>
+                </a:solidFill>
+                <a:latin typeface="Consolas"/>
+              </a:rPr>
+              <a:t>                        f"CRITICAL: autonomous refund of ₹{amount:,.2f} exceeds the "</a:t>
+            </a:r>
+          </a:p>
+          <a:p>
+            <a:pPr>
+              <a:lnSpc>
+                <a:spcPct val="100000"/>
+              </a:lnSpc>
+              <a:spcBef>
+                <a:spcPts val="0"/>
+              </a:spcBef>
+              <a:spcAft>
+                <a:spcPts val="0"/>
+              </a:spcAft>
+            </a:pPr>
+            <a:r>
+              <a:rPr sz="1000" b="0" i="0">
+                <a:solidFill>
+                  <a:srgbClr val="CDD6F4"/>
+                </a:solidFill>
+                <a:latin typeface="Consolas"/>
+              </a:rPr>
+              <a:t>                        f"₹{AUTO_REFUND_LIMIT_INR:,.0f} auto-refund limit."</a:t>
+            </a:r>
+          </a:p>
+          <a:p>
+            <a:pPr>
+              <a:lnSpc>
+                <a:spcPct val="100000"/>
+              </a:lnSpc>
+              <a:spcBef>
+                <a:spcPts val="0"/>
+              </a:spcBef>
+              <a:spcAft>
+                <a:spcPts val="0"/>
+              </a:spcAft>
+            </a:pPr>
+            <a:r>
+              <a:rPr sz="1000" b="0" i="0">
+                <a:solidFill>
+                  <a:srgbClr val="CDD6F4"/>
+                </a:solidFill>
+                <a:latin typeface="Consolas"/>
+              </a:rPr>
+              <a:t>                    ),</a:t>
+            </a:r>
+          </a:p>
+          <a:p>
+            <a:pPr>
+              <a:lnSpc>
+                <a:spcPct val="100000"/>
+              </a:lnSpc>
+              <a:spcBef>
+                <a:spcPts val="0"/>
+              </a:spcBef>
+              <a:spcAft>
+                <a:spcPts val="0"/>
+              </a:spcAft>
+            </a:pPr>
+            <a:r>
+              <a:rPr sz="1000" b="0" i="0">
+                <a:solidFill>
+                  <a:srgbClr val="CDD6F4"/>
+                </a:solidFill>
+                <a:latin typeface="Consolas"/>
+              </a:rPr>
+              <a:t>                    user_message=(</a:t>
+            </a:r>
+          </a:p>
+          <a:p>
+            <a:pPr>
+              <a:lnSpc>
+                <a:spcPct val="100000"/>
+              </a:lnSpc>
+              <a:spcBef>
+                <a:spcPts val="0"/>
+              </a:spcBef>
+              <a:spcAft>
+                <a:spcPts val="0"/>
+              </a:spcAft>
+            </a:pPr>
+            <a:r>
+              <a:rPr sz="1000" b="0" i="0">
+                <a:solidFill>
+                  <a:srgbClr val="CDD6F4"/>
+                </a:solidFill>
+                <a:latin typeface="Consolas"/>
+              </a:rPr>
+              <a:t>                        "We've detected an issue with your request processing and "</a:t>
+            </a:r>
+          </a:p>
+          <a:p>
+            <a:pPr>
+              <a:lnSpc>
+                <a:spcPct val="100000"/>
+              </a:lnSpc>
+              <a:spcBef>
+                <a:spcPts val="0"/>
+              </a:spcBef>
+              <a:spcAft>
+                <a:spcPts val="0"/>
+              </a:spcAft>
+            </a:pPr>
+            <a:r>
+              <a:rPr sz="1000" b="0" i="0">
+                <a:solidFill>
+                  <a:srgbClr val="CDD6F4"/>
+                </a:solidFill>
+                <a:latin typeface="Consolas"/>
+              </a:rPr>
+              <a:t>                        "have paused it for safety. Our team has been alerted and "</a:t>
+            </a:r>
+          </a:p>
+          <a:p>
+            <a:pPr>
+              <a:lnSpc>
+                <a:spcPct val="100000"/>
+              </a:lnSpc>
+              <a:spcBef>
+                <a:spcPts val="0"/>
+              </a:spcBef>
+              <a:spcAft>
+                <a:spcPts val="0"/>
+              </a:spcAft>
+            </a:pPr>
+            <a:r>
+              <a:rPr sz="1000" b="0" i="0">
+                <a:solidFill>
+                  <a:srgbClr val="CDD6F4"/>
+                </a:solidFill>
+                <a:latin typeface="Consolas"/>
+              </a:rPr>
+              <a:t>                        "will reach out to you within 24 hours to resolve this."</a:t>
+            </a:r>
+          </a:p>
+          <a:p>
+            <a:pPr>
+              <a:lnSpc>
+                <a:spcPct val="100000"/>
+              </a:lnSpc>
+              <a:spcBef>
+                <a:spcPts val="0"/>
+              </a:spcBef>
+              <a:spcAft>
+                <a:spcPts val="0"/>
+              </a:spcAft>
+            </a:pPr>
+            <a:r>
+              <a:rPr sz="1000" b="0" i="0">
+                <a:solidFill>
+                  <a:srgbClr val="CDD6F4"/>
+                </a:solidFill>
+                <a:latin typeface="Consolas"/>
+              </a:rPr>
+              <a:t>                    ),</a:t>
+            </a:r>
+          </a:p>
+          <a:p>
+            <a:pPr>
+              <a:lnSpc>
+                <a:spcPct val="100000"/>
+              </a:lnSpc>
+              <a:spcBef>
+                <a:spcPts val="0"/>
+              </a:spcBef>
+              <a:spcAft>
+                <a:spcPts val="0"/>
+              </a:spcAft>
+            </a:pPr>
+            <a:r>
+              <a:rPr sz="1000" b="0" i="0">
+                <a:solidFill>
+                  <a:srgbClr val="CDD6F4"/>
+                </a:solidFill>
+                <a:latin typeface="Consolas"/>
+              </a:rPr>
+              <a:t>                )</a:t>
+            </a:r>
+          </a:p>
+          <a:p>
+            <a:pPr>
+              <a:lnSpc>
+                <a:spcPct val="100000"/>
+              </a:lnSpc>
+              <a:spcBef>
+                <a:spcPts val="0"/>
+              </a:spcBef>
+              <a:spcAft>
+                <a:spcPts val="0"/>
+              </a:spcAft>
+            </a:pPr>
+            <a:r>
+              <a:rPr sz="1000" b="0" i="0">
+                <a:solidFill>
+                  <a:srgbClr val="CDD6F4"/>
+                </a:solidFill>
+                <a:latin typeface="Consolas"/>
+              </a:rPr>
+              <a:t>        return GuardrailVerdict.allow()</a:t>
+            </a:r>
+          </a:p>
+          <a:p>
+            <a:pPr>
+              <a:lnSpc>
+                <a:spcPct val="100000"/>
+              </a:lnSpc>
+              <a:spcBef>
+                <a:spcPts val="0"/>
+              </a:spcBef>
+              <a:spcAft>
+                <a:spcPts val="0"/>
+              </a:spcAft>
+            </a:pPr>
+            <a:r>
+              <a:rPr sz="1000" b="0" i="0">
+                <a:solidFill>
+                  <a:srgbClr val="CDD6F4"/>
+                </a:solidFill>
+                <a:latin typeface="Consolas"/>
+              </a:rPr>
+              <a:t>        # ... (continues in source)</a:t>
             </a:r>
           </a:p>
         </p:txBody>

</xml_diff>